<commit_message>
updates through lecture 32
</commit_message>
<xml_diff>
--- a/Lecture_Slides/PH 123 Lecture 31.pptx
+++ b/Lecture_Slides/PH 123 Lecture 31.pptx
@@ -197,7 +197,7 @@
 <file path=ppt/revisionInfo.xml><?xml version="1.0" encoding="utf-8"?>
 <p1510:revInfo xmlns:a="http://schemas.openxmlformats.org/drawingml/2006/main" xmlns:r="http://schemas.openxmlformats.org/officeDocument/2006/relationships" xmlns:p1510="http://schemas.microsoft.com/office/powerpoint/2015/10/main">
   <p1510:revLst>
-    <p1510:client id="{E4F61A1E-E133-4318-A760-48BD8E5D6B9C}" v="59" dt="2025-07-01T20:50:01.083"/>
+    <p1510:client id="{0C32E2C0-EC0C-490D-B723-92DA2E82AD7C}" v="24" dt="2026-03-19T20:39:29.963"/>
   </p1510:revLst>
 </p1510:revInfo>
 </file>
@@ -205,524 +205,177 @@
 <file path=ppt/changesInfos/changesInfo1.xml><?xml version="1.0" encoding="utf-8"?>
 <pc:chgInfo xmlns:a="http://schemas.openxmlformats.org/drawingml/2006/main" xmlns:r="http://schemas.openxmlformats.org/officeDocument/2006/relationships" xmlns:ac="http://schemas.microsoft.com/office/drawing/2013/main/command" xmlns:pc="http://schemas.microsoft.com/office/powerpoint/2013/main/command">
   <pc:docChgLst>
-    <pc:chgData name="Lines, Todd" userId="afaf7c3a-e8aa-4568-882a-02ad8f9e19b0" providerId="ADAL" clId="{E4F61A1E-E133-4318-A760-48BD8E5D6B9C}"/>
-    <pc:docChg chg="undo custSel addSld delSld modSld sldOrd">
-      <pc:chgData name="Lines, Todd" userId="afaf7c3a-e8aa-4568-882a-02ad8f9e19b0" providerId="ADAL" clId="{E4F61A1E-E133-4318-A760-48BD8E5D6B9C}" dt="2025-07-01T20:50:01.081" v="392"/>
+    <pc:chgData name="Lines, Todd" userId="afaf7c3a-e8aa-4568-882a-02ad8f9e19b0" providerId="ADAL" clId="{5FF5AC1B-ABA9-43D7-A1E3-2D92732CD6E2}"/>
+    <pc:docChg chg="custSel modSld">
+      <pc:chgData name="Lines, Todd" userId="afaf7c3a-e8aa-4568-882a-02ad8f9e19b0" providerId="ADAL" clId="{5FF5AC1B-ABA9-43D7-A1E3-2D92732CD6E2}" dt="2026-03-19T20:39:33.640" v="73" actId="21"/>
       <pc:docMkLst>
         <pc:docMk/>
       </pc:docMkLst>
       <pc:sldChg chg="modSp mod">
-        <pc:chgData name="Lines, Todd" userId="afaf7c3a-e8aa-4568-882a-02ad8f9e19b0" providerId="ADAL" clId="{E4F61A1E-E133-4318-A760-48BD8E5D6B9C}" dt="2025-06-20T22:13:19.232" v="9" actId="20577"/>
-        <pc:sldMkLst>
-          <pc:docMk/>
-          <pc:sldMk cId="0" sldId="256"/>
-        </pc:sldMkLst>
-        <pc:spChg chg="mod">
-          <ac:chgData name="Lines, Todd" userId="afaf7c3a-e8aa-4568-882a-02ad8f9e19b0" providerId="ADAL" clId="{E4F61A1E-E133-4318-A760-48BD8E5D6B9C}" dt="2025-06-20T22:13:19.232" v="9" actId="20577"/>
-          <ac:spMkLst>
-            <pc:docMk/>
-            <pc:sldMk cId="0" sldId="256"/>
-            <ac:spMk id="2" creationId="{00000000-0000-0000-0000-000000000000}"/>
-          </ac:spMkLst>
-        </pc:spChg>
-      </pc:sldChg>
-      <pc:sldChg chg="addSp delSp modSp new mod modClrScheme chgLayout">
-        <pc:chgData name="Lines, Todd" userId="afaf7c3a-e8aa-4568-882a-02ad8f9e19b0" providerId="ADAL" clId="{E4F61A1E-E133-4318-A760-48BD8E5D6B9C}" dt="2025-06-24T18:37:26.004" v="77" actId="478"/>
-        <pc:sldMkLst>
-          <pc:docMk/>
-          <pc:sldMk cId="666363481" sldId="270"/>
-        </pc:sldMkLst>
-        <pc:spChg chg="add mod ord">
-          <ac:chgData name="Lines, Todd" userId="afaf7c3a-e8aa-4568-882a-02ad8f9e19b0" providerId="ADAL" clId="{E4F61A1E-E133-4318-A760-48BD8E5D6B9C}" dt="2025-06-20T22:13:32.113" v="14" actId="20577"/>
-          <ac:spMkLst>
-            <pc:docMk/>
-            <pc:sldMk cId="666363481" sldId="270"/>
-            <ac:spMk id="4" creationId="{A6A7AA64-2F51-7C37-E69D-DA42EDEADCEB}"/>
-          </ac:spMkLst>
-        </pc:spChg>
-        <pc:spChg chg="add mod ord">
-          <ac:chgData name="Lines, Todd" userId="afaf7c3a-e8aa-4568-882a-02ad8f9e19b0" providerId="ADAL" clId="{E4F61A1E-E133-4318-A760-48BD8E5D6B9C}" dt="2025-06-20T22:13:30.179" v="11" actId="700"/>
-          <ac:spMkLst>
-            <pc:docMk/>
-            <pc:sldMk cId="666363481" sldId="270"/>
-            <ac:spMk id="5" creationId="{EFEC5EAC-2E28-222C-1628-A3A56417C870}"/>
-          </ac:spMkLst>
-        </pc:spChg>
-      </pc:sldChg>
-      <pc:sldChg chg="add">
-        <pc:chgData name="Lines, Todd" userId="afaf7c3a-e8aa-4568-882a-02ad8f9e19b0" providerId="ADAL" clId="{E4F61A1E-E133-4318-A760-48BD8E5D6B9C}" dt="2025-06-20T22:14:47.837" v="15"/>
-        <pc:sldMkLst>
-          <pc:docMk/>
-          <pc:sldMk cId="0" sldId="271"/>
-        </pc:sldMkLst>
-      </pc:sldChg>
-      <pc:sldChg chg="add">
-        <pc:chgData name="Lines, Todd" userId="afaf7c3a-e8aa-4568-882a-02ad8f9e19b0" providerId="ADAL" clId="{E4F61A1E-E133-4318-A760-48BD8E5D6B9C}" dt="2025-06-20T22:14:47.837" v="15"/>
-        <pc:sldMkLst>
-          <pc:docMk/>
-          <pc:sldMk cId="0" sldId="272"/>
-        </pc:sldMkLst>
-      </pc:sldChg>
-      <pc:sldChg chg="addSp delSp modSp add mod">
-        <pc:chgData name="Lines, Todd" userId="afaf7c3a-e8aa-4568-882a-02ad8f9e19b0" providerId="ADAL" clId="{E4F61A1E-E133-4318-A760-48BD8E5D6B9C}" dt="2025-06-20T22:21:21.269" v="30" actId="21"/>
+        <pc:chgData name="Lines, Todd" userId="afaf7c3a-e8aa-4568-882a-02ad8f9e19b0" providerId="ADAL" clId="{5FF5AC1B-ABA9-43D7-A1E3-2D92732CD6E2}" dt="2026-03-19T16:40:46.205" v="0" actId="113"/>
         <pc:sldMkLst>
           <pc:docMk/>
           <pc:sldMk cId="0" sldId="273"/>
         </pc:sldMkLst>
         <pc:spChg chg="mod">
-          <ac:chgData name="Lines, Todd" userId="afaf7c3a-e8aa-4568-882a-02ad8f9e19b0" providerId="ADAL" clId="{E4F61A1E-E133-4318-A760-48BD8E5D6B9C}" dt="2025-06-20T22:20:38.733" v="22" actId="27636"/>
+          <ac:chgData name="Lines, Todd" userId="afaf7c3a-e8aa-4568-882a-02ad8f9e19b0" providerId="ADAL" clId="{5FF5AC1B-ABA9-43D7-A1E3-2D92732CD6E2}" dt="2026-03-19T16:40:46.205" v="0" actId="113"/>
           <ac:spMkLst>
             <pc:docMk/>
             <pc:sldMk cId="0" sldId="273"/>
             <ac:spMk id="28675" creationId="{00000000-0000-0000-0000-000000000000}"/>
           </ac:spMkLst>
         </pc:spChg>
-        <pc:picChg chg="add mod">
-          <ac:chgData name="Lines, Todd" userId="afaf7c3a-e8aa-4568-882a-02ad8f9e19b0" providerId="ADAL" clId="{E4F61A1E-E133-4318-A760-48BD8E5D6B9C}" dt="2025-06-20T22:20:45.063" v="24" actId="1076"/>
-          <ac:picMkLst>
-            <pc:docMk/>
-            <pc:sldMk cId="0" sldId="273"/>
-            <ac:picMk id="2" creationId="{878FCFEB-7C18-DCB1-C819-06F58CA1493F}"/>
-          </ac:picMkLst>
-        </pc:picChg>
       </pc:sldChg>
-      <pc:sldChg chg="addSp delSp modSp add mod">
-        <pc:chgData name="Lines, Todd" userId="afaf7c3a-e8aa-4568-882a-02ad8f9e19b0" providerId="ADAL" clId="{E4F61A1E-E133-4318-A760-48BD8E5D6B9C}" dt="2025-06-20T22:20:02.030" v="20" actId="1076"/>
-        <pc:sldMkLst>
-          <pc:docMk/>
-          <pc:sldMk cId="0" sldId="274"/>
-        </pc:sldMkLst>
-        <pc:spChg chg="add mod">
-          <ac:chgData name="Lines, Todd" userId="afaf7c3a-e8aa-4568-882a-02ad8f9e19b0" providerId="ADAL" clId="{E4F61A1E-E133-4318-A760-48BD8E5D6B9C}" dt="2025-06-20T22:19:53.039" v="16" actId="478"/>
-          <ac:spMkLst>
-            <pc:docMk/>
-            <pc:sldMk cId="0" sldId="274"/>
-            <ac:spMk id="3" creationId="{2CC9C444-06D0-76B1-7BA7-2BA427740A4C}"/>
-          </ac:spMkLst>
-        </pc:spChg>
-        <pc:picChg chg="add mod">
-          <ac:chgData name="Lines, Todd" userId="afaf7c3a-e8aa-4568-882a-02ad8f9e19b0" providerId="ADAL" clId="{E4F61A1E-E133-4318-A760-48BD8E5D6B9C}" dt="2025-06-20T22:20:02.030" v="20" actId="1076"/>
-          <ac:picMkLst>
-            <pc:docMk/>
-            <pc:sldMk cId="0" sldId="274"/>
-            <ac:picMk id="2050" creationId="{492380C8-87EE-D09A-0AA9-B43EA1CF4C8A}"/>
-          </ac:picMkLst>
-        </pc:picChg>
-      </pc:sldChg>
-      <pc:sldChg chg="addSp modSp add mod">
-        <pc:chgData name="Lines, Todd" userId="afaf7c3a-e8aa-4568-882a-02ad8f9e19b0" providerId="ADAL" clId="{E4F61A1E-E133-4318-A760-48BD8E5D6B9C}" dt="2025-06-20T22:21:05.006" v="28" actId="1076"/>
-        <pc:sldMkLst>
-          <pc:docMk/>
-          <pc:sldMk cId="0" sldId="275"/>
-        </pc:sldMkLst>
-        <pc:spChg chg="mod">
-          <ac:chgData name="Lines, Todd" userId="afaf7c3a-e8aa-4568-882a-02ad8f9e19b0" providerId="ADAL" clId="{E4F61A1E-E133-4318-A760-48BD8E5D6B9C}" dt="2025-06-20T22:21:05.006" v="28" actId="1076"/>
-          <ac:spMkLst>
-            <pc:docMk/>
-            <pc:sldMk cId="0" sldId="275"/>
-            <ac:spMk id="30723" creationId="{00000000-0000-0000-0000-000000000000}"/>
-          </ac:spMkLst>
-        </pc:spChg>
-        <pc:picChg chg="add mod">
-          <ac:chgData name="Lines, Todd" userId="afaf7c3a-e8aa-4568-882a-02ad8f9e19b0" providerId="ADAL" clId="{E4F61A1E-E133-4318-A760-48BD8E5D6B9C}" dt="2025-06-20T22:21:00.913" v="27"/>
-          <ac:picMkLst>
-            <pc:docMk/>
-            <pc:sldMk cId="0" sldId="275"/>
-            <ac:picMk id="2" creationId="{8D93CAD3-5F86-BB13-87F3-311ED2E6EF90}"/>
-          </ac:picMkLst>
-        </pc:picChg>
-      </pc:sldChg>
-      <pc:sldChg chg="add">
-        <pc:chgData name="Lines, Todd" userId="afaf7c3a-e8aa-4568-882a-02ad8f9e19b0" providerId="ADAL" clId="{E4F61A1E-E133-4318-A760-48BD8E5D6B9C}" dt="2025-06-20T22:14:47.837" v="15"/>
+      <pc:sldChg chg="addSp delSp modSp mod">
+        <pc:chgData name="Lines, Todd" userId="afaf7c3a-e8aa-4568-882a-02ad8f9e19b0" providerId="ADAL" clId="{5FF5AC1B-ABA9-43D7-A1E3-2D92732CD6E2}" dt="2026-03-19T20:00:34.635" v="32" actId="1076"/>
         <pc:sldMkLst>
           <pc:docMk/>
           <pc:sldMk cId="0" sldId="276"/>
         </pc:sldMkLst>
-      </pc:sldChg>
-      <pc:sldChg chg="add">
-        <pc:chgData name="Lines, Todd" userId="afaf7c3a-e8aa-4568-882a-02ad8f9e19b0" providerId="ADAL" clId="{E4F61A1E-E133-4318-A760-48BD8E5D6B9C}" dt="2025-06-20T22:14:47.837" v="15"/>
-        <pc:sldMkLst>
-          <pc:docMk/>
-          <pc:sldMk cId="0" sldId="277"/>
-        </pc:sldMkLst>
-      </pc:sldChg>
-      <pc:sldChg chg="add">
-        <pc:chgData name="Lines, Todd" userId="afaf7c3a-e8aa-4568-882a-02ad8f9e19b0" providerId="ADAL" clId="{E4F61A1E-E133-4318-A760-48BD8E5D6B9C}" dt="2025-06-20T22:14:47.837" v="15"/>
-        <pc:sldMkLst>
-          <pc:docMk/>
-          <pc:sldMk cId="0" sldId="278"/>
-        </pc:sldMkLst>
-      </pc:sldChg>
-      <pc:sldChg chg="add">
-        <pc:chgData name="Lines, Todd" userId="afaf7c3a-e8aa-4568-882a-02ad8f9e19b0" providerId="ADAL" clId="{E4F61A1E-E133-4318-A760-48BD8E5D6B9C}" dt="2025-06-20T22:14:47.837" v="15"/>
-        <pc:sldMkLst>
-          <pc:docMk/>
-          <pc:sldMk cId="0" sldId="279"/>
-        </pc:sldMkLst>
-      </pc:sldChg>
-      <pc:sldChg chg="add">
-        <pc:chgData name="Lines, Todd" userId="afaf7c3a-e8aa-4568-882a-02ad8f9e19b0" providerId="ADAL" clId="{E4F61A1E-E133-4318-A760-48BD8E5D6B9C}" dt="2025-06-20T22:14:47.837" v="15"/>
-        <pc:sldMkLst>
-          <pc:docMk/>
-          <pc:sldMk cId="0" sldId="280"/>
-        </pc:sldMkLst>
-      </pc:sldChg>
-      <pc:sldChg chg="addSp delSp modSp add mod">
-        <pc:chgData name="Lines, Todd" userId="afaf7c3a-e8aa-4568-882a-02ad8f9e19b0" providerId="ADAL" clId="{E4F61A1E-E133-4318-A760-48BD8E5D6B9C}" dt="2025-06-20T22:23:50.715" v="35" actId="1076"/>
-        <pc:sldMkLst>
-          <pc:docMk/>
-          <pc:sldMk cId="0" sldId="281"/>
-        </pc:sldMkLst>
-        <pc:spChg chg="add mod">
-          <ac:chgData name="Lines, Todd" userId="afaf7c3a-e8aa-4568-882a-02ad8f9e19b0" providerId="ADAL" clId="{E4F61A1E-E133-4318-A760-48BD8E5D6B9C}" dt="2025-06-20T22:23:42.401" v="31" actId="478"/>
+        <pc:spChg chg="add del mod">
+          <ac:chgData name="Lines, Todd" userId="afaf7c3a-e8aa-4568-882a-02ad8f9e19b0" providerId="ADAL" clId="{5FF5AC1B-ABA9-43D7-A1E3-2D92732CD6E2}" dt="2026-03-19T19:27:51.921" v="3" actId="478"/>
           <ac:spMkLst>
             <pc:docMk/>
-            <pc:sldMk cId="0" sldId="281"/>
-            <ac:spMk id="3" creationId="{3A0C0553-5C3D-1AA7-21FB-A675A3C3CC7A}"/>
+            <pc:sldMk cId="0" sldId="276"/>
+            <ac:spMk id="2" creationId="{6EF1F1D5-3038-BF94-F09A-D6197D139338}"/>
           </ac:spMkLst>
         </pc:spChg>
-        <pc:spChg chg="mod">
-          <ac:chgData name="Lines, Todd" userId="afaf7c3a-e8aa-4568-882a-02ad8f9e19b0" providerId="ADAL" clId="{E4F61A1E-E133-4318-A760-48BD8E5D6B9C}" dt="2025-06-20T22:23:50.715" v="35" actId="1076"/>
+        <pc:spChg chg="del">
+          <ac:chgData name="Lines, Todd" userId="afaf7c3a-e8aa-4568-882a-02ad8f9e19b0" providerId="ADAL" clId="{5FF5AC1B-ABA9-43D7-A1E3-2D92732CD6E2}" dt="2026-03-19T19:56:43.692" v="13" actId="478"/>
           <ac:spMkLst>
             <pc:docMk/>
-            <pc:sldMk cId="0" sldId="281"/>
-            <ac:spMk id="34819" creationId="{00000000-0000-0000-0000-000000000000}"/>
+            <pc:sldMk cId="0" sldId="276"/>
+            <ac:spMk id="3" creationId="{00000000-0000-0000-0000-000000000000}"/>
           </ac:spMkLst>
         </pc:spChg>
-        <pc:picChg chg="add mod">
-          <ac:chgData name="Lines, Todd" userId="afaf7c3a-e8aa-4568-882a-02ad8f9e19b0" providerId="ADAL" clId="{E4F61A1E-E133-4318-A760-48BD8E5D6B9C}" dt="2025-06-20T22:23:45.718" v="33" actId="1076"/>
+        <pc:spChg chg="add mod">
+          <ac:chgData name="Lines, Todd" userId="afaf7c3a-e8aa-4568-882a-02ad8f9e19b0" providerId="ADAL" clId="{5FF5AC1B-ABA9-43D7-A1E3-2D92732CD6E2}" dt="2026-03-19T20:00:34.635" v="32" actId="1076"/>
+          <ac:spMkLst>
+            <pc:docMk/>
+            <pc:sldMk cId="0" sldId="276"/>
+            <ac:spMk id="6" creationId="{00000000-0000-0000-0000-000000000000}"/>
+          </ac:spMkLst>
+        </pc:spChg>
+        <pc:graphicFrameChg chg="del mod replId">
+          <ac:chgData name="Lines, Todd" userId="afaf7c3a-e8aa-4568-882a-02ad8f9e19b0" providerId="ADAL" clId="{5FF5AC1B-ABA9-43D7-A1E3-2D92732CD6E2}" dt="2026-03-19T19:59:31.041" v="17"/>
+          <ac:graphicFrameMkLst>
+            <pc:docMk/>
+            <pc:sldMk cId="0" sldId="276"/>
+            <ac:graphicFrameMk id="12" creationId="{00000000-0000-0000-0000-000000000000}"/>
+          </ac:graphicFrameMkLst>
+        </pc:graphicFrameChg>
+        <pc:picChg chg="add del">
+          <ac:chgData name="Lines, Todd" userId="afaf7c3a-e8aa-4568-882a-02ad8f9e19b0" providerId="ADAL" clId="{5FF5AC1B-ABA9-43D7-A1E3-2D92732CD6E2}" dt="2026-03-19T19:55:51.026" v="6" actId="478"/>
           <ac:picMkLst>
             <pc:docMk/>
-            <pc:sldMk cId="0" sldId="281"/>
-            <ac:picMk id="3074" creationId="{659DE769-E2A5-1336-C496-DD7357C3E79C}"/>
+            <pc:sldMk cId="0" sldId="276"/>
+            <ac:picMk id="5" creationId="{24AA7A06-9513-193A-4573-E94603CD4A75}"/>
+          </ac:picMkLst>
+        </pc:picChg>
+        <pc:picChg chg="add del">
+          <ac:chgData name="Lines, Todd" userId="afaf7c3a-e8aa-4568-882a-02ad8f9e19b0" providerId="ADAL" clId="{5FF5AC1B-ABA9-43D7-A1E3-2D92732CD6E2}" dt="2026-03-19T19:56:28.993" v="8" actId="478"/>
+          <ac:picMkLst>
+            <pc:docMk/>
+            <pc:sldMk cId="0" sldId="276"/>
+            <ac:picMk id="8" creationId="{F0D91BCC-A710-BC96-C23C-125F4224E4CE}"/>
+          </ac:picMkLst>
+        </pc:picChg>
+        <pc:picChg chg="add mod">
+          <ac:chgData name="Lines, Todd" userId="afaf7c3a-e8aa-4568-882a-02ad8f9e19b0" providerId="ADAL" clId="{5FF5AC1B-ABA9-43D7-A1E3-2D92732CD6E2}" dt="2026-03-19T19:56:39.470" v="12" actId="1076"/>
+          <ac:picMkLst>
+            <pc:docMk/>
+            <pc:sldMk cId="0" sldId="276"/>
+            <ac:picMk id="10" creationId="{792FC827-A1F7-B12C-79D4-C253C5889CF4}"/>
+          </ac:picMkLst>
+        </pc:picChg>
+        <pc:picChg chg="del mod">
+          <ac:chgData name="Lines, Todd" userId="afaf7c3a-e8aa-4568-882a-02ad8f9e19b0" providerId="ADAL" clId="{5FF5AC1B-ABA9-43D7-A1E3-2D92732CD6E2}" dt="2026-03-19T19:56:54.907" v="15" actId="21"/>
+          <ac:picMkLst>
+            <pc:docMk/>
+            <pc:sldMk cId="0" sldId="276"/>
+            <ac:picMk id="11" creationId="{2360958B-13D7-16A1-7A20-C03FE61E3C9F}"/>
+          </ac:picMkLst>
+        </pc:picChg>
+        <pc:picChg chg="del">
+          <ac:chgData name="Lines, Todd" userId="afaf7c3a-e8aa-4568-882a-02ad8f9e19b0" providerId="ADAL" clId="{5FF5AC1B-ABA9-43D7-A1E3-2D92732CD6E2}" dt="2026-03-19T19:54:41.807" v="4" actId="478"/>
+          <ac:picMkLst>
+            <pc:docMk/>
+            <pc:sldMk cId="0" sldId="276"/>
+            <ac:picMk id="1033" creationId="{00000000-0000-0000-0000-000000000000}"/>
           </ac:picMkLst>
         </pc:picChg>
       </pc:sldChg>
-      <pc:sldChg chg="add">
-        <pc:chgData name="Lines, Todd" userId="afaf7c3a-e8aa-4568-882a-02ad8f9e19b0" providerId="ADAL" clId="{E4F61A1E-E133-4318-A760-48BD8E5D6B9C}" dt="2025-06-20T22:14:47.837" v="15"/>
-        <pc:sldMkLst>
-          <pc:docMk/>
-          <pc:sldMk cId="0" sldId="282"/>
-        </pc:sldMkLst>
-      </pc:sldChg>
-      <pc:sldChg chg="add">
-        <pc:chgData name="Lines, Todd" userId="afaf7c3a-e8aa-4568-882a-02ad8f9e19b0" providerId="ADAL" clId="{E4F61A1E-E133-4318-A760-48BD8E5D6B9C}" dt="2025-06-20T22:14:47.837" v="15"/>
-        <pc:sldMkLst>
-          <pc:docMk/>
-          <pc:sldMk cId="0" sldId="283"/>
-        </pc:sldMkLst>
-      </pc:sldChg>
-      <pc:sldChg chg="addSp delSp modSp add mod">
-        <pc:chgData name="Lines, Todd" userId="afaf7c3a-e8aa-4568-882a-02ad8f9e19b0" providerId="ADAL" clId="{E4F61A1E-E133-4318-A760-48BD8E5D6B9C}" dt="2025-06-26T19:16:33.752" v="291" actId="21"/>
-        <pc:sldMkLst>
-          <pc:docMk/>
-          <pc:sldMk cId="0" sldId="284"/>
-        </pc:sldMkLst>
-        <pc:spChg chg="add mod">
-          <ac:chgData name="Lines, Todd" userId="afaf7c3a-e8aa-4568-882a-02ad8f9e19b0" providerId="ADAL" clId="{E4F61A1E-E133-4318-A760-48BD8E5D6B9C}" dt="2025-06-26T19:16:03.675" v="286" actId="1076"/>
-          <ac:spMkLst>
-            <pc:docMk/>
-            <pc:sldMk cId="0" sldId="284"/>
-            <ac:spMk id="5" creationId="{FAA125CE-E28A-F4CD-57BC-39B638091605}"/>
-          </ac:spMkLst>
-        </pc:spChg>
-        <pc:spChg chg="add mod">
-          <ac:chgData name="Lines, Todd" userId="afaf7c3a-e8aa-4568-882a-02ad8f9e19b0" providerId="ADAL" clId="{E4F61A1E-E133-4318-A760-48BD8E5D6B9C}" dt="2025-06-26T19:16:00.202" v="285" actId="1076"/>
-          <ac:spMkLst>
-            <pc:docMk/>
-            <pc:sldMk cId="0" sldId="284"/>
-            <ac:spMk id="6" creationId="{C2AD90A3-3F04-EDDB-5593-D0D2D7CA07A5}"/>
-          </ac:spMkLst>
-        </pc:spChg>
-      </pc:sldChg>
-      <pc:sldChg chg="add">
-        <pc:chgData name="Lines, Todd" userId="afaf7c3a-e8aa-4568-882a-02ad8f9e19b0" providerId="ADAL" clId="{E4F61A1E-E133-4318-A760-48BD8E5D6B9C}" dt="2025-06-20T22:14:47.837" v="15"/>
-        <pc:sldMkLst>
-          <pc:docMk/>
-          <pc:sldMk cId="0" sldId="285"/>
-        </pc:sldMkLst>
-      </pc:sldChg>
-      <pc:sldChg chg="add">
-        <pc:chgData name="Lines, Todd" userId="afaf7c3a-e8aa-4568-882a-02ad8f9e19b0" providerId="ADAL" clId="{E4F61A1E-E133-4318-A760-48BD8E5D6B9C}" dt="2025-06-20T22:14:47.837" v="15"/>
-        <pc:sldMkLst>
-          <pc:docMk/>
-          <pc:sldMk cId="0" sldId="286"/>
-        </pc:sldMkLst>
-      </pc:sldChg>
-      <pc:sldChg chg="add">
-        <pc:chgData name="Lines, Todd" userId="afaf7c3a-e8aa-4568-882a-02ad8f9e19b0" providerId="ADAL" clId="{E4F61A1E-E133-4318-A760-48BD8E5D6B9C}" dt="2025-06-20T22:14:47.837" v="15"/>
-        <pc:sldMkLst>
-          <pc:docMk/>
-          <pc:sldMk cId="0" sldId="287"/>
-        </pc:sldMkLst>
-      </pc:sldChg>
-      <pc:sldChg chg="addSp delSp modSp add mod">
-        <pc:chgData name="Lines, Todd" userId="afaf7c3a-e8aa-4568-882a-02ad8f9e19b0" providerId="ADAL" clId="{E4F61A1E-E133-4318-A760-48BD8E5D6B9C}" dt="2025-06-20T22:30:30.758" v="40" actId="1076"/>
-        <pc:sldMkLst>
-          <pc:docMk/>
-          <pc:sldMk cId="0" sldId="288"/>
-        </pc:sldMkLst>
-        <pc:spChg chg="add mod">
-          <ac:chgData name="Lines, Todd" userId="afaf7c3a-e8aa-4568-882a-02ad8f9e19b0" providerId="ADAL" clId="{E4F61A1E-E133-4318-A760-48BD8E5D6B9C}" dt="2025-06-20T22:30:22.652" v="36" actId="478"/>
-          <ac:spMkLst>
-            <pc:docMk/>
-            <pc:sldMk cId="0" sldId="288"/>
-            <ac:spMk id="3" creationId="{C2C80A5C-BFAF-D6DA-33F2-766CA7802E3A}"/>
-          </ac:spMkLst>
-        </pc:spChg>
-        <pc:picChg chg="add mod">
-          <ac:chgData name="Lines, Todd" userId="afaf7c3a-e8aa-4568-882a-02ad8f9e19b0" providerId="ADAL" clId="{E4F61A1E-E133-4318-A760-48BD8E5D6B9C}" dt="2025-06-20T22:30:30.758" v="40" actId="1076"/>
-          <ac:picMkLst>
-            <pc:docMk/>
-            <pc:sldMk cId="0" sldId="288"/>
-            <ac:picMk id="6146" creationId="{99E43834-C08D-6B08-37E0-FA642E66AD9E}"/>
-          </ac:picMkLst>
-        </pc:picChg>
-      </pc:sldChg>
-      <pc:sldChg chg="add">
-        <pc:chgData name="Lines, Todd" userId="afaf7c3a-e8aa-4568-882a-02ad8f9e19b0" providerId="ADAL" clId="{E4F61A1E-E133-4318-A760-48BD8E5D6B9C}" dt="2025-06-20T22:14:47.837" v="15"/>
-        <pc:sldMkLst>
-          <pc:docMk/>
-          <pc:sldMk cId="0" sldId="289"/>
-        </pc:sldMkLst>
-      </pc:sldChg>
-      <pc:sldChg chg="add">
-        <pc:chgData name="Lines, Todd" userId="afaf7c3a-e8aa-4568-882a-02ad8f9e19b0" providerId="ADAL" clId="{E4F61A1E-E133-4318-A760-48BD8E5D6B9C}" dt="2025-06-20T22:14:47.837" v="15"/>
-        <pc:sldMkLst>
-          <pc:docMk/>
-          <pc:sldMk cId="0" sldId="290"/>
-        </pc:sldMkLst>
-      </pc:sldChg>
-      <pc:sldChg chg="add">
-        <pc:chgData name="Lines, Todd" userId="afaf7c3a-e8aa-4568-882a-02ad8f9e19b0" providerId="ADAL" clId="{E4F61A1E-E133-4318-A760-48BD8E5D6B9C}" dt="2025-06-20T22:14:47.837" v="15"/>
-        <pc:sldMkLst>
-          <pc:docMk/>
-          <pc:sldMk cId="0" sldId="291"/>
-        </pc:sldMkLst>
-      </pc:sldChg>
-      <pc:sldChg chg="add">
-        <pc:chgData name="Lines, Todd" userId="afaf7c3a-e8aa-4568-882a-02ad8f9e19b0" providerId="ADAL" clId="{E4F61A1E-E133-4318-A760-48BD8E5D6B9C}" dt="2025-06-20T22:14:47.837" v="15"/>
-        <pc:sldMkLst>
-          <pc:docMk/>
-          <pc:sldMk cId="0" sldId="292"/>
-        </pc:sldMkLst>
-      </pc:sldChg>
-      <pc:sldChg chg="add">
-        <pc:chgData name="Lines, Todd" userId="afaf7c3a-e8aa-4568-882a-02ad8f9e19b0" providerId="ADAL" clId="{E4F61A1E-E133-4318-A760-48BD8E5D6B9C}" dt="2025-06-20T22:14:47.837" v="15"/>
-        <pc:sldMkLst>
-          <pc:docMk/>
-          <pc:sldMk cId="0" sldId="293"/>
-        </pc:sldMkLst>
-      </pc:sldChg>
-      <pc:sldChg chg="add ord">
-        <pc:chgData name="Lines, Todd" userId="afaf7c3a-e8aa-4568-882a-02ad8f9e19b0" providerId="ADAL" clId="{E4F61A1E-E133-4318-A760-48BD8E5D6B9C}" dt="2025-06-27T15:39:16.406" v="341"/>
-        <pc:sldMkLst>
-          <pc:docMk/>
-          <pc:sldMk cId="0" sldId="294"/>
-        </pc:sldMkLst>
-      </pc:sldChg>
-      <pc:sldChg chg="add ord">
-        <pc:chgData name="Lines, Todd" userId="afaf7c3a-e8aa-4568-882a-02ad8f9e19b0" providerId="ADAL" clId="{E4F61A1E-E133-4318-A760-48BD8E5D6B9C}" dt="2025-06-27T15:39:07.932" v="339"/>
-        <pc:sldMkLst>
-          <pc:docMk/>
-          <pc:sldMk cId="0" sldId="295"/>
-        </pc:sldMkLst>
-      </pc:sldChg>
-      <pc:sldChg chg="add">
-        <pc:chgData name="Lines, Todd" userId="afaf7c3a-e8aa-4568-882a-02ad8f9e19b0" providerId="ADAL" clId="{E4F61A1E-E133-4318-A760-48BD8E5D6B9C}" dt="2025-06-20T22:14:47.837" v="15"/>
-        <pc:sldMkLst>
-          <pc:docMk/>
-          <pc:sldMk cId="0" sldId="296"/>
-        </pc:sldMkLst>
-      </pc:sldChg>
-      <pc:sldChg chg="add">
-        <pc:chgData name="Lines, Todd" userId="afaf7c3a-e8aa-4568-882a-02ad8f9e19b0" providerId="ADAL" clId="{E4F61A1E-E133-4318-A760-48BD8E5D6B9C}" dt="2025-06-20T22:14:47.837" v="15"/>
-        <pc:sldMkLst>
-          <pc:docMk/>
-          <pc:sldMk cId="3526645629" sldId="297"/>
-        </pc:sldMkLst>
-      </pc:sldChg>
-      <pc:sldChg chg="add ord">
-        <pc:chgData name="Lines, Todd" userId="afaf7c3a-e8aa-4568-882a-02ad8f9e19b0" providerId="ADAL" clId="{E4F61A1E-E133-4318-A760-48BD8E5D6B9C}" dt="2025-06-27T15:39:24.847" v="343"/>
-        <pc:sldMkLst>
-          <pc:docMk/>
-          <pc:sldMk cId="0" sldId="298"/>
-        </pc:sldMkLst>
-      </pc:sldChg>
-      <pc:sldChg chg="addSp delSp modSp new del mod">
-        <pc:chgData name="Lines, Todd" userId="afaf7c3a-e8aa-4568-882a-02ad8f9e19b0" providerId="ADAL" clId="{E4F61A1E-E133-4318-A760-48BD8E5D6B9C}" dt="2025-06-24T18:37:22.973" v="75" actId="47"/>
-        <pc:sldMkLst>
-          <pc:docMk/>
-          <pc:sldMk cId="18341271" sldId="299"/>
-        </pc:sldMkLst>
-      </pc:sldChg>
-      <pc:sldChg chg="add">
-        <pc:chgData name="Lines, Todd" userId="afaf7c3a-e8aa-4568-882a-02ad8f9e19b0" providerId="ADAL" clId="{E4F61A1E-E133-4318-A760-48BD8E5D6B9C}" dt="2025-06-24T18:29:47.119" v="48"/>
-        <pc:sldMkLst>
-          <pc:docMk/>
-          <pc:sldMk cId="1879521254" sldId="300"/>
-        </pc:sldMkLst>
-      </pc:sldChg>
-      <pc:sldChg chg="add">
-        <pc:chgData name="Lines, Todd" userId="afaf7c3a-e8aa-4568-882a-02ad8f9e19b0" providerId="ADAL" clId="{E4F61A1E-E133-4318-A760-48BD8E5D6B9C}" dt="2025-06-24T18:29:47.119" v="48"/>
-        <pc:sldMkLst>
-          <pc:docMk/>
-          <pc:sldMk cId="2870393114" sldId="301"/>
-        </pc:sldMkLst>
-      </pc:sldChg>
-      <pc:sldChg chg="add">
-        <pc:chgData name="Lines, Todd" userId="afaf7c3a-e8aa-4568-882a-02ad8f9e19b0" providerId="ADAL" clId="{E4F61A1E-E133-4318-A760-48BD8E5D6B9C}" dt="2025-06-24T18:29:47.119" v="48"/>
-        <pc:sldMkLst>
-          <pc:docMk/>
-          <pc:sldMk cId="2664515775" sldId="302"/>
-        </pc:sldMkLst>
-      </pc:sldChg>
-      <pc:sldChg chg="add ord">
-        <pc:chgData name="Lines, Todd" userId="afaf7c3a-e8aa-4568-882a-02ad8f9e19b0" providerId="ADAL" clId="{E4F61A1E-E133-4318-A760-48BD8E5D6B9C}" dt="2025-06-26T20:48:47.613" v="319"/>
-        <pc:sldMkLst>
-          <pc:docMk/>
-          <pc:sldMk cId="0" sldId="303"/>
-        </pc:sldMkLst>
-      </pc:sldChg>
-      <pc:sldChg chg="add">
-        <pc:chgData name="Lines, Todd" userId="afaf7c3a-e8aa-4568-882a-02ad8f9e19b0" providerId="ADAL" clId="{E4F61A1E-E133-4318-A760-48BD8E5D6B9C}" dt="2025-06-24T18:29:47.119" v="48"/>
-        <pc:sldMkLst>
-          <pc:docMk/>
-          <pc:sldMk cId="429714220" sldId="304"/>
-        </pc:sldMkLst>
-      </pc:sldChg>
-      <pc:sldChg chg="add">
-        <pc:chgData name="Lines, Todd" userId="afaf7c3a-e8aa-4568-882a-02ad8f9e19b0" providerId="ADAL" clId="{E4F61A1E-E133-4318-A760-48BD8E5D6B9C}" dt="2025-06-24T18:29:47.119" v="48"/>
-        <pc:sldMkLst>
-          <pc:docMk/>
-          <pc:sldMk cId="2185010735" sldId="305"/>
-        </pc:sldMkLst>
-      </pc:sldChg>
-      <pc:sldChg chg="add">
-        <pc:chgData name="Lines, Todd" userId="afaf7c3a-e8aa-4568-882a-02ad8f9e19b0" providerId="ADAL" clId="{E4F61A1E-E133-4318-A760-48BD8E5D6B9C}" dt="2025-06-24T18:29:47.119" v="48"/>
-        <pc:sldMkLst>
-          <pc:docMk/>
-          <pc:sldMk cId="56680486" sldId="306"/>
-        </pc:sldMkLst>
-      </pc:sldChg>
-      <pc:sldChg chg="add">
-        <pc:chgData name="Lines, Todd" userId="afaf7c3a-e8aa-4568-882a-02ad8f9e19b0" providerId="ADAL" clId="{E4F61A1E-E133-4318-A760-48BD8E5D6B9C}" dt="2025-06-24T18:29:47.119" v="48"/>
-        <pc:sldMkLst>
-          <pc:docMk/>
-          <pc:sldMk cId="3608737307" sldId="307"/>
-        </pc:sldMkLst>
-      </pc:sldChg>
-      <pc:sldChg chg="add">
-        <pc:chgData name="Lines, Todd" userId="afaf7c3a-e8aa-4568-882a-02ad8f9e19b0" providerId="ADAL" clId="{E4F61A1E-E133-4318-A760-48BD8E5D6B9C}" dt="2025-06-24T18:29:47.119" v="48"/>
-        <pc:sldMkLst>
-          <pc:docMk/>
-          <pc:sldMk cId="3688465666" sldId="308"/>
-        </pc:sldMkLst>
-      </pc:sldChg>
-      <pc:sldChg chg="add">
-        <pc:chgData name="Lines, Todd" userId="afaf7c3a-e8aa-4568-882a-02ad8f9e19b0" providerId="ADAL" clId="{E4F61A1E-E133-4318-A760-48BD8E5D6B9C}" dt="2025-06-24T18:29:47.119" v="48"/>
-        <pc:sldMkLst>
-          <pc:docMk/>
-          <pc:sldMk cId="2342598283" sldId="309"/>
-        </pc:sldMkLst>
-      </pc:sldChg>
-      <pc:sldChg chg="add">
-        <pc:chgData name="Lines, Todd" userId="afaf7c3a-e8aa-4568-882a-02ad8f9e19b0" providerId="ADAL" clId="{E4F61A1E-E133-4318-A760-48BD8E5D6B9C}" dt="2025-06-24T18:29:47.119" v="48"/>
-        <pc:sldMkLst>
-          <pc:docMk/>
-          <pc:sldMk cId="1075177029" sldId="310"/>
-        </pc:sldMkLst>
-      </pc:sldChg>
-      <pc:sldChg chg="add">
-        <pc:chgData name="Lines, Todd" userId="afaf7c3a-e8aa-4568-882a-02ad8f9e19b0" providerId="ADAL" clId="{E4F61A1E-E133-4318-A760-48BD8E5D6B9C}" dt="2025-06-24T18:29:47.119" v="48"/>
-        <pc:sldMkLst>
-          <pc:docMk/>
-          <pc:sldMk cId="4239158132" sldId="311"/>
-        </pc:sldMkLst>
-      </pc:sldChg>
-      <pc:sldChg chg="add">
-        <pc:chgData name="Lines, Todd" userId="afaf7c3a-e8aa-4568-882a-02ad8f9e19b0" providerId="ADAL" clId="{E4F61A1E-E133-4318-A760-48BD8E5D6B9C}" dt="2025-06-24T18:29:47.119" v="48"/>
-        <pc:sldMkLst>
-          <pc:docMk/>
-          <pc:sldMk cId="4016644960" sldId="312"/>
-        </pc:sldMkLst>
-      </pc:sldChg>
-      <pc:sldChg chg="add">
-        <pc:chgData name="Lines, Todd" userId="afaf7c3a-e8aa-4568-882a-02ad8f9e19b0" providerId="ADAL" clId="{E4F61A1E-E133-4318-A760-48BD8E5D6B9C}" dt="2025-06-24T18:29:47.119" v="48"/>
-        <pc:sldMkLst>
-          <pc:docMk/>
-          <pc:sldMk cId="2537048809" sldId="313"/>
-        </pc:sldMkLst>
-      </pc:sldChg>
-      <pc:sldChg chg="add">
-        <pc:chgData name="Lines, Todd" userId="afaf7c3a-e8aa-4568-882a-02ad8f9e19b0" providerId="ADAL" clId="{E4F61A1E-E133-4318-A760-48BD8E5D6B9C}" dt="2025-06-24T18:29:47.119" v="48"/>
-        <pc:sldMkLst>
-          <pc:docMk/>
-          <pc:sldMk cId="2868793490" sldId="314"/>
-        </pc:sldMkLst>
-      </pc:sldChg>
-      <pc:sldChg chg="addSp delSp modSp new mod">
-        <pc:chgData name="Lines, Todd" userId="afaf7c3a-e8aa-4568-882a-02ad8f9e19b0" providerId="ADAL" clId="{E4F61A1E-E133-4318-A760-48BD8E5D6B9C}" dt="2025-06-24T18:31:11.143" v="63" actId="403"/>
-        <pc:sldMkLst>
-          <pc:docMk/>
-          <pc:sldMk cId="4023657050" sldId="315"/>
-        </pc:sldMkLst>
-        <pc:spChg chg="add mod">
-          <ac:chgData name="Lines, Todd" userId="afaf7c3a-e8aa-4568-882a-02ad8f9e19b0" providerId="ADAL" clId="{E4F61A1E-E133-4318-A760-48BD8E5D6B9C}" dt="2025-06-24T18:31:11.143" v="63" actId="403"/>
-          <ac:spMkLst>
-            <pc:docMk/>
-            <pc:sldMk cId="4023657050" sldId="315"/>
-            <ac:spMk id="5" creationId="{2C0246CA-346E-89FF-35A2-638230745B40}"/>
-          </ac:spMkLst>
-        </pc:spChg>
-        <pc:spChg chg="add mod">
-          <ac:chgData name="Lines, Todd" userId="afaf7c3a-e8aa-4568-882a-02ad8f9e19b0" providerId="ADAL" clId="{E4F61A1E-E133-4318-A760-48BD8E5D6B9C}" dt="2025-06-24T18:31:11.143" v="63" actId="403"/>
-          <ac:spMkLst>
-            <pc:docMk/>
-            <pc:sldMk cId="4023657050" sldId="315"/>
-            <ac:spMk id="6" creationId="{819F6547-E870-D1E3-0947-E6C35632CA67}"/>
-          </ac:spMkLst>
-        </pc:spChg>
-        <pc:spChg chg="add mod">
-          <ac:chgData name="Lines, Todd" userId="afaf7c3a-e8aa-4568-882a-02ad8f9e19b0" providerId="ADAL" clId="{E4F61A1E-E133-4318-A760-48BD8E5D6B9C}" dt="2025-06-24T18:31:11.143" v="63" actId="403"/>
-          <ac:spMkLst>
-            <pc:docMk/>
-            <pc:sldMk cId="4023657050" sldId="315"/>
-            <ac:spMk id="7" creationId="{CB9DC3E2-59E6-C571-9CB8-639210FBED79}"/>
-          </ac:spMkLst>
-        </pc:spChg>
-        <pc:picChg chg="add mod">
-          <ac:chgData name="Lines, Todd" userId="afaf7c3a-e8aa-4568-882a-02ad8f9e19b0" providerId="ADAL" clId="{E4F61A1E-E133-4318-A760-48BD8E5D6B9C}" dt="2025-06-24T18:31:07.107" v="61" actId="1076"/>
-          <ac:picMkLst>
-            <pc:docMk/>
-            <pc:sldMk cId="4023657050" sldId="315"/>
-            <ac:picMk id="4" creationId="{429DEDF1-92F1-67FD-5013-B4759CDAF10A}"/>
-          </ac:picMkLst>
-        </pc:picChg>
-      </pc:sldChg>
-      <pc:sldChg chg="addSp delSp modSp new mod">
-        <pc:chgData name="Lines, Todd" userId="afaf7c3a-e8aa-4568-882a-02ad8f9e19b0" providerId="ADAL" clId="{E4F61A1E-E133-4318-A760-48BD8E5D6B9C}" dt="2025-06-24T18:32:12.600" v="68" actId="1076"/>
+      <pc:sldChg chg="addSp delSp modSp mod">
+        <pc:chgData name="Lines, Todd" userId="afaf7c3a-e8aa-4568-882a-02ad8f9e19b0" providerId="ADAL" clId="{5FF5AC1B-ABA9-43D7-A1E3-2D92732CD6E2}" dt="2026-03-19T20:33:46.884" v="48" actId="21"/>
         <pc:sldMkLst>
           <pc:docMk/>
           <pc:sldMk cId="3116191251" sldId="316"/>
         </pc:sldMkLst>
+        <pc:picChg chg="del mod">
+          <ac:chgData name="Lines, Todd" userId="afaf7c3a-e8aa-4568-882a-02ad8f9e19b0" providerId="ADAL" clId="{5FF5AC1B-ABA9-43D7-A1E3-2D92732CD6E2}" dt="2026-03-19T20:30:45.924" v="34" actId="21"/>
+          <ac:picMkLst>
+            <pc:docMk/>
+            <pc:sldMk cId="3116191251" sldId="316"/>
+            <ac:picMk id="2" creationId="{6ABC38D9-5133-07CC-E080-99379D2C1023}"/>
+          </ac:picMkLst>
+        </pc:picChg>
         <pc:picChg chg="add mod">
-          <ac:chgData name="Lines, Todd" userId="afaf7c3a-e8aa-4568-882a-02ad8f9e19b0" providerId="ADAL" clId="{E4F61A1E-E133-4318-A760-48BD8E5D6B9C}" dt="2025-06-24T18:32:12.600" v="68" actId="1076"/>
+          <ac:chgData name="Lines, Todd" userId="afaf7c3a-e8aa-4568-882a-02ad8f9e19b0" providerId="ADAL" clId="{5FF5AC1B-ABA9-43D7-A1E3-2D92732CD6E2}" dt="2026-03-19T20:31:35.680" v="38" actId="14100"/>
+          <ac:picMkLst>
+            <pc:docMk/>
+            <pc:sldMk cId="3116191251" sldId="316"/>
+            <ac:picMk id="4" creationId="{A7809F78-A3C5-82A2-407B-08F57BC00C4A}"/>
+          </ac:picMkLst>
+        </pc:picChg>
+        <pc:picChg chg="del">
+          <ac:chgData name="Lines, Todd" userId="afaf7c3a-e8aa-4568-882a-02ad8f9e19b0" providerId="ADAL" clId="{5FF5AC1B-ABA9-43D7-A1E3-2D92732CD6E2}" dt="2026-03-19T20:31:24.613" v="35" actId="478"/>
           <ac:picMkLst>
             <pc:docMk/>
             <pc:sldMk cId="3116191251" sldId="316"/>
             <ac:picMk id="5" creationId="{C122EEE4-87EE-D806-AD40-EA58B31179AB}"/>
           </ac:picMkLst>
         </pc:picChg>
+        <pc:picChg chg="add del">
+          <ac:chgData name="Lines, Todd" userId="afaf7c3a-e8aa-4568-882a-02ad8f9e19b0" providerId="ADAL" clId="{5FF5AC1B-ABA9-43D7-A1E3-2D92732CD6E2}" dt="2026-03-19T20:33:37.139" v="46" actId="21"/>
+          <ac:picMkLst>
+            <pc:docMk/>
+            <pc:sldMk cId="3116191251" sldId="316"/>
+            <ac:picMk id="7" creationId="{DA674FBD-8CB4-CAD0-8BE9-79CC943CCF3C}"/>
+          </ac:picMkLst>
+        </pc:picChg>
+        <pc:picChg chg="del mod">
+          <ac:chgData name="Lines, Todd" userId="afaf7c3a-e8aa-4568-882a-02ad8f9e19b0" providerId="ADAL" clId="{5FF5AC1B-ABA9-43D7-A1E3-2D92732CD6E2}" dt="2026-03-19T20:33:46.884" v="48" actId="21"/>
+          <ac:picMkLst>
+            <pc:docMk/>
+            <pc:sldMk cId="3116191251" sldId="316"/>
+            <ac:picMk id="8" creationId="{DA97C55C-F4A1-D4B5-2E5F-11FB3E1CB046}"/>
+          </ac:picMkLst>
+        </pc:picChg>
       </pc:sldChg>
-      <pc:sldChg chg="addSp delSp modSp new mod">
-        <pc:chgData name="Lines, Todd" userId="afaf7c3a-e8aa-4568-882a-02ad8f9e19b0" providerId="ADAL" clId="{E4F61A1E-E133-4318-A760-48BD8E5D6B9C}" dt="2025-06-24T18:32:50.029" v="74" actId="1076"/>
+      <pc:sldChg chg="addSp delSp modSp mod">
+        <pc:chgData name="Lines, Todd" userId="afaf7c3a-e8aa-4568-882a-02ad8f9e19b0" providerId="ADAL" clId="{5FF5AC1B-ABA9-43D7-A1E3-2D92732CD6E2}" dt="2026-03-19T20:33:12.579" v="44" actId="21"/>
         <pc:sldMkLst>
           <pc:docMk/>
           <pc:sldMk cId="2785678226" sldId="317"/>
         </pc:sldMkLst>
         <pc:picChg chg="add mod">
-          <ac:chgData name="Lines, Todd" userId="afaf7c3a-e8aa-4568-882a-02ad8f9e19b0" providerId="ADAL" clId="{E4F61A1E-E133-4318-A760-48BD8E5D6B9C}" dt="2025-06-24T18:32:50.029" v="74" actId="1076"/>
+          <ac:chgData name="Lines, Todd" userId="afaf7c3a-e8aa-4568-882a-02ad8f9e19b0" providerId="ADAL" clId="{5FF5AC1B-ABA9-43D7-A1E3-2D92732CD6E2}" dt="2026-03-19T20:32:59.201" v="42" actId="14100"/>
+          <ac:picMkLst>
+            <pc:docMk/>
+            <pc:sldMk cId="2785678226" sldId="317"/>
+            <ac:picMk id="3" creationId="{288FAC4D-BEF0-38D3-CFD8-AF56530DC211}"/>
+          </ac:picMkLst>
+        </pc:picChg>
+        <pc:picChg chg="del mod">
+          <ac:chgData name="Lines, Todd" userId="afaf7c3a-e8aa-4568-882a-02ad8f9e19b0" providerId="ADAL" clId="{5FF5AC1B-ABA9-43D7-A1E3-2D92732CD6E2}" dt="2026-03-19T20:33:12.579" v="44" actId="21"/>
+          <ac:picMkLst>
+            <pc:docMk/>
+            <pc:sldMk cId="2785678226" sldId="317"/>
+            <ac:picMk id="4" creationId="{B01EA28A-A121-2D9C-DB4F-E9F88E1526D8}"/>
+          </ac:picMkLst>
+        </pc:picChg>
+        <pc:picChg chg="del">
+          <ac:chgData name="Lines, Todd" userId="afaf7c3a-e8aa-4568-882a-02ad8f9e19b0" providerId="ADAL" clId="{5FF5AC1B-ABA9-43D7-A1E3-2D92732CD6E2}" dt="2026-03-19T20:32:48.596" v="39" actId="478"/>
           <ac:picMkLst>
             <pc:docMk/>
             <pc:sldMk cId="2785678226" sldId="317"/>
@@ -730,257 +383,99 @@
           </ac:picMkLst>
         </pc:picChg>
       </pc:sldChg>
-      <pc:sldChg chg="addSp delSp modSp new mod">
-        <pc:chgData name="Lines, Todd" userId="afaf7c3a-e8aa-4568-882a-02ad8f9e19b0" providerId="ADAL" clId="{E4F61A1E-E133-4318-A760-48BD8E5D6B9C}" dt="2025-06-24T18:41:09.082" v="253" actId="21"/>
-        <pc:sldMkLst>
-          <pc:docMk/>
-          <pc:sldMk cId="3232158416" sldId="318"/>
-        </pc:sldMkLst>
-        <pc:spChg chg="add mod">
-          <ac:chgData name="Lines, Todd" userId="afaf7c3a-e8aa-4568-882a-02ad8f9e19b0" providerId="ADAL" clId="{E4F61A1E-E133-4318-A760-48BD8E5D6B9C}" dt="2025-06-24T18:39:08.398" v="157" actId="1076"/>
-          <ac:spMkLst>
-            <pc:docMk/>
-            <pc:sldMk cId="3232158416" sldId="318"/>
-            <ac:spMk id="8" creationId="{D479A763-A536-A79E-A1E2-3476B5C8EB9D}"/>
-          </ac:spMkLst>
-        </pc:spChg>
-        <pc:spChg chg="add mod">
-          <ac:chgData name="Lines, Todd" userId="afaf7c3a-e8aa-4568-882a-02ad8f9e19b0" providerId="ADAL" clId="{E4F61A1E-E133-4318-A760-48BD8E5D6B9C}" dt="2025-06-24T18:39:20.312" v="162" actId="1076"/>
-          <ac:spMkLst>
-            <pc:docMk/>
-            <pc:sldMk cId="3232158416" sldId="318"/>
-            <ac:spMk id="9" creationId="{0A6CC88E-126D-EBCA-A4F7-2D6D1589B9FD}"/>
-          </ac:spMkLst>
-        </pc:spChg>
-        <pc:spChg chg="add mod">
-          <ac:chgData name="Lines, Todd" userId="afaf7c3a-e8aa-4568-882a-02ad8f9e19b0" providerId="ADAL" clId="{E4F61A1E-E133-4318-A760-48BD8E5D6B9C}" dt="2025-06-24T18:40:02.904" v="245" actId="207"/>
-          <ac:spMkLst>
-            <pc:docMk/>
-            <pc:sldMk cId="3232158416" sldId="318"/>
-            <ac:spMk id="12" creationId="{EC015484-2A02-486C-E081-B5F26EDD6F19}"/>
-          </ac:spMkLst>
-        </pc:spChg>
-        <pc:picChg chg="add mod">
-          <ac:chgData name="Lines, Todd" userId="afaf7c3a-e8aa-4568-882a-02ad8f9e19b0" providerId="ADAL" clId="{E4F61A1E-E133-4318-A760-48BD8E5D6B9C}" dt="2025-06-24T18:39:15.156" v="160" actId="1076"/>
-          <ac:picMkLst>
-            <pc:docMk/>
-            <pc:sldMk cId="3232158416" sldId="318"/>
-            <ac:picMk id="5" creationId="{CE447034-93A3-1264-8299-9517AB6CBAEA}"/>
-          </ac:picMkLst>
-        </pc:picChg>
-        <pc:cxnChg chg="add mod">
-          <ac:chgData name="Lines, Todd" userId="afaf7c3a-e8aa-4568-882a-02ad8f9e19b0" providerId="ADAL" clId="{E4F61A1E-E133-4318-A760-48BD8E5D6B9C}" dt="2025-06-24T18:39:10.218" v="158" actId="1076"/>
-          <ac:cxnSpMkLst>
-            <pc:docMk/>
-            <pc:sldMk cId="3232158416" sldId="318"/>
-            <ac:cxnSpMk id="7" creationId="{14A7B888-2BD5-F70D-5F7C-207C66DCDEA9}"/>
-          </ac:cxnSpMkLst>
-        </pc:cxnChg>
-        <pc:cxnChg chg="add mod">
-          <ac:chgData name="Lines, Todd" userId="afaf7c3a-e8aa-4568-882a-02ad8f9e19b0" providerId="ADAL" clId="{E4F61A1E-E133-4318-A760-48BD8E5D6B9C}" dt="2025-06-24T18:39:22.900" v="163" actId="14100"/>
-          <ac:cxnSpMkLst>
-            <pc:docMk/>
-            <pc:sldMk cId="3232158416" sldId="318"/>
-            <ac:cxnSpMk id="10" creationId="{AD7F889D-D0EE-4284-646E-E20664C041C9}"/>
-          </ac:cxnSpMkLst>
-        </pc:cxnChg>
-        <pc:cxnChg chg="add mod">
-          <ac:chgData name="Lines, Todd" userId="afaf7c3a-e8aa-4568-882a-02ad8f9e19b0" providerId="ADAL" clId="{E4F61A1E-E133-4318-A760-48BD8E5D6B9C}" dt="2025-06-24T18:40:17.996" v="249" actId="208"/>
-          <ac:cxnSpMkLst>
-            <pc:docMk/>
-            <pc:sldMk cId="3232158416" sldId="318"/>
-            <ac:cxnSpMk id="15" creationId="{F3E323C9-D769-9BB3-1754-D64494198ED2}"/>
-          </ac:cxnSpMkLst>
-        </pc:cxnChg>
-      </pc:sldChg>
-      <pc:sldChg chg="addSp delSp modSp new mod">
-        <pc:chgData name="Lines, Todd" userId="afaf7c3a-e8aa-4568-882a-02ad8f9e19b0" providerId="ADAL" clId="{E4F61A1E-E133-4318-A760-48BD8E5D6B9C}" dt="2025-06-26T20:30:46.817" v="299" actId="21"/>
-        <pc:sldMkLst>
-          <pc:docMk/>
-          <pc:sldMk cId="1084085587" sldId="319"/>
-        </pc:sldMkLst>
-        <pc:picChg chg="add">
-          <ac:chgData name="Lines, Todd" userId="afaf7c3a-e8aa-4568-882a-02ad8f9e19b0" providerId="ADAL" clId="{E4F61A1E-E133-4318-A760-48BD8E5D6B9C}" dt="2025-06-26T20:26:37.922" v="293" actId="22"/>
-          <ac:picMkLst>
-            <pc:docMk/>
-            <pc:sldMk cId="1084085587" sldId="319"/>
-            <ac:picMk id="5" creationId="{3F3492FC-9AC3-7EA2-56EB-2D2F1DFD4849}"/>
-          </ac:picMkLst>
-        </pc:picChg>
-      </pc:sldChg>
-      <pc:sldChg chg="addSp delSp modSp new del mod">
-        <pc:chgData name="Lines, Todd" userId="afaf7c3a-e8aa-4568-882a-02ad8f9e19b0" providerId="ADAL" clId="{E4F61A1E-E133-4318-A760-48BD8E5D6B9C}" dt="2025-06-26T20:39:00.305" v="306" actId="47"/>
-        <pc:sldMkLst>
-          <pc:docMk/>
-          <pc:sldMk cId="200666680" sldId="320"/>
-        </pc:sldMkLst>
-      </pc:sldChg>
-      <pc:sldChg chg="addSp delSp modSp new mod">
-        <pc:chgData name="Lines, Todd" userId="afaf7c3a-e8aa-4568-882a-02ad8f9e19b0" providerId="ADAL" clId="{E4F61A1E-E133-4318-A760-48BD8E5D6B9C}" dt="2025-06-26T20:39:17.071" v="309" actId="21"/>
-        <pc:sldMkLst>
-          <pc:docMk/>
-          <pc:sldMk cId="2132777228" sldId="321"/>
-        </pc:sldMkLst>
-        <pc:picChg chg="add">
-          <ac:chgData name="Lines, Todd" userId="afaf7c3a-e8aa-4568-882a-02ad8f9e19b0" providerId="ADAL" clId="{E4F61A1E-E133-4318-A760-48BD8E5D6B9C}" dt="2025-06-26T20:38:40.515" v="305" actId="22"/>
-          <ac:picMkLst>
-            <pc:docMk/>
-            <pc:sldMk cId="2132777228" sldId="321"/>
-            <ac:picMk id="8" creationId="{52A92F10-6B02-6EC7-F49B-28FC9EB7D9D1}"/>
-          </ac:picMkLst>
-        </pc:picChg>
-        <pc:picChg chg="add">
-          <ac:chgData name="Lines, Todd" userId="afaf7c3a-e8aa-4568-882a-02ad8f9e19b0" providerId="ADAL" clId="{E4F61A1E-E133-4318-A760-48BD8E5D6B9C}" dt="2025-06-26T20:39:00.757" v="307" actId="22"/>
-          <ac:picMkLst>
-            <pc:docMk/>
-            <pc:sldMk cId="2132777228" sldId="321"/>
-            <ac:picMk id="10" creationId="{54EE3DDA-CE94-20E8-93A0-5FFADCB12E26}"/>
-          </ac:picMkLst>
-        </pc:picChg>
-      </pc:sldChg>
-      <pc:sldChg chg="addSp delSp modSp new mod">
-        <pc:chgData name="Lines, Todd" userId="afaf7c3a-e8aa-4568-882a-02ad8f9e19b0" providerId="ADAL" clId="{E4F61A1E-E133-4318-A760-48BD8E5D6B9C}" dt="2025-06-26T20:40:10.860" v="313" actId="21"/>
-        <pc:sldMkLst>
-          <pc:docMk/>
-          <pc:sldMk cId="3931262058" sldId="322"/>
-        </pc:sldMkLst>
-        <pc:picChg chg="add">
-          <ac:chgData name="Lines, Todd" userId="afaf7c3a-e8aa-4568-882a-02ad8f9e19b0" providerId="ADAL" clId="{E4F61A1E-E133-4318-A760-48BD8E5D6B9C}" dt="2025-06-26T20:39:59.812" v="311" actId="22"/>
-          <ac:picMkLst>
-            <pc:docMk/>
-            <pc:sldMk cId="3931262058" sldId="322"/>
-            <ac:picMk id="5" creationId="{BC132914-2EDA-C9E5-B8C8-4D7374087DF4}"/>
-          </ac:picMkLst>
-        </pc:picChg>
-      </pc:sldChg>
-      <pc:sldChg chg="addSp modSp new mod">
-        <pc:chgData name="Lines, Todd" userId="afaf7c3a-e8aa-4568-882a-02ad8f9e19b0" providerId="ADAL" clId="{E4F61A1E-E133-4318-A760-48BD8E5D6B9C}" dt="2025-06-26T20:42:30.794" v="317" actId="1076"/>
-        <pc:sldMkLst>
-          <pc:docMk/>
-          <pc:sldMk cId="148952240" sldId="323"/>
-        </pc:sldMkLst>
-        <pc:picChg chg="add mod">
-          <ac:chgData name="Lines, Todd" userId="afaf7c3a-e8aa-4568-882a-02ad8f9e19b0" providerId="ADAL" clId="{E4F61A1E-E133-4318-A760-48BD8E5D6B9C}" dt="2025-06-26T20:42:30.794" v="317" actId="1076"/>
-          <ac:picMkLst>
-            <pc:docMk/>
-            <pc:sldMk cId="148952240" sldId="323"/>
-            <ac:picMk id="5" creationId="{1E9AE7CA-61DB-7B33-A675-173DF424BD67}"/>
-          </ac:picMkLst>
-        </pc:picChg>
-      </pc:sldChg>
-      <pc:sldChg chg="add del">
-        <pc:chgData name="Lines, Todd" userId="afaf7c3a-e8aa-4568-882a-02ad8f9e19b0" providerId="ADAL" clId="{E4F61A1E-E133-4318-A760-48BD8E5D6B9C}" dt="2025-06-27T15:36:29.453" v="337" actId="47"/>
-        <pc:sldMkLst>
-          <pc:docMk/>
-          <pc:sldMk cId="1094709690" sldId="324"/>
-        </pc:sldMkLst>
-      </pc:sldChg>
-      <pc:sldChg chg="addSp modSp add mod">
-        <pc:chgData name="Lines, Todd" userId="afaf7c3a-e8aa-4568-882a-02ad8f9e19b0" providerId="ADAL" clId="{E4F61A1E-E133-4318-A760-48BD8E5D6B9C}" dt="2025-06-27T15:36:19.261" v="336" actId="14100"/>
-        <pc:sldMkLst>
-          <pc:docMk/>
-          <pc:sldMk cId="897264754" sldId="325"/>
-        </pc:sldMkLst>
-        <pc:picChg chg="add mod">
-          <ac:chgData name="Lines, Todd" userId="afaf7c3a-e8aa-4568-882a-02ad8f9e19b0" providerId="ADAL" clId="{E4F61A1E-E133-4318-A760-48BD8E5D6B9C}" dt="2025-06-27T15:36:09.398" v="333" actId="1076"/>
-          <ac:picMkLst>
-            <pc:docMk/>
-            <pc:sldMk cId="897264754" sldId="325"/>
-            <ac:picMk id="4" creationId="{8085895F-348D-A2DA-D362-36E45400892E}"/>
-          </ac:picMkLst>
-        </pc:picChg>
-        <pc:picChg chg="add mod">
-          <ac:chgData name="Lines, Todd" userId="afaf7c3a-e8aa-4568-882a-02ad8f9e19b0" providerId="ADAL" clId="{E4F61A1E-E133-4318-A760-48BD8E5D6B9C}" dt="2025-06-27T15:36:03.506" v="331" actId="1076"/>
-          <ac:picMkLst>
-            <pc:docMk/>
-            <pc:sldMk cId="897264754" sldId="325"/>
-            <ac:picMk id="8" creationId="{FE25E81E-632E-AFD6-B513-0B1AE0699A04}"/>
-          </ac:picMkLst>
-        </pc:picChg>
-        <pc:cxnChg chg="add mod">
-          <ac:chgData name="Lines, Todd" userId="afaf7c3a-e8aa-4568-882a-02ad8f9e19b0" providerId="ADAL" clId="{E4F61A1E-E133-4318-A760-48BD8E5D6B9C}" dt="2025-06-27T15:35:37.099" v="327" actId="208"/>
-          <ac:cxnSpMkLst>
-            <pc:docMk/>
-            <pc:sldMk cId="897264754" sldId="325"/>
-            <ac:cxnSpMk id="7" creationId="{E75C954E-FF12-8EC6-56A4-6C62C9964D69}"/>
-          </ac:cxnSpMkLst>
-        </pc:cxnChg>
-        <pc:cxnChg chg="add mod">
-          <ac:chgData name="Lines, Todd" userId="afaf7c3a-e8aa-4568-882a-02ad8f9e19b0" providerId="ADAL" clId="{E4F61A1E-E133-4318-A760-48BD8E5D6B9C}" dt="2025-06-27T15:36:19.261" v="336" actId="14100"/>
-          <ac:cxnSpMkLst>
-            <pc:docMk/>
-            <pc:sldMk cId="897264754" sldId="325"/>
-            <ac:cxnSpMk id="9" creationId="{497ED4B6-0D66-6C15-2781-37D2165155F7}"/>
-          </ac:cxnSpMkLst>
-        </pc:cxnChg>
-      </pc:sldChg>
-      <pc:sldChg chg="addSp delSp modSp new mod">
-        <pc:chgData name="Lines, Todd" userId="afaf7c3a-e8aa-4568-882a-02ad8f9e19b0" providerId="ADAL" clId="{E4F61A1E-E133-4318-A760-48BD8E5D6B9C}" dt="2025-06-27T15:42:56.780" v="349" actId="1076"/>
+      <pc:sldChg chg="addSp delSp modSp mod">
+        <pc:chgData name="Lines, Todd" userId="afaf7c3a-e8aa-4568-882a-02ad8f9e19b0" providerId="ADAL" clId="{5FF5AC1B-ABA9-43D7-A1E3-2D92732CD6E2}" dt="2026-03-19T20:39:33.640" v="73" actId="21"/>
         <pc:sldMkLst>
           <pc:docMk/>
           <pc:sldMk cId="1891487831" sldId="326"/>
         </pc:sldMkLst>
-        <pc:picChg chg="add mod">
-          <ac:chgData name="Lines, Todd" userId="afaf7c3a-e8aa-4568-882a-02ad8f9e19b0" providerId="ADAL" clId="{E4F61A1E-E133-4318-A760-48BD8E5D6B9C}" dt="2025-06-27T15:42:56.780" v="349" actId="1076"/>
+        <pc:picChg chg="add del mod">
+          <ac:chgData name="Lines, Todd" userId="afaf7c3a-e8aa-4568-882a-02ad8f9e19b0" providerId="ADAL" clId="{5FF5AC1B-ABA9-43D7-A1E3-2D92732CD6E2}" dt="2026-03-19T20:37:51.035" v="64" actId="21"/>
           <ac:picMkLst>
             <pc:docMk/>
             <pc:sldMk cId="1891487831" sldId="326"/>
-            <ac:picMk id="5" creationId="{3C99C0E4-FA7F-AFA9-2839-D7AB8090D955}"/>
+            <ac:picMk id="3" creationId="{9FB12249-CB96-B44A-1483-A21F3DC8DFBF}"/>
+          </ac:picMkLst>
+        </pc:picChg>
+        <pc:picChg chg="del">
+          <ac:chgData name="Lines, Todd" userId="afaf7c3a-e8aa-4568-882a-02ad8f9e19b0" providerId="ADAL" clId="{5FF5AC1B-ABA9-43D7-A1E3-2D92732CD6E2}" dt="2026-03-19T20:37:57.567" v="65" actId="21"/>
+          <ac:picMkLst>
+            <pc:docMk/>
+            <pc:sldMk cId="1891487831" sldId="326"/>
+            <ac:picMk id="4" creationId="{832D7F00-5136-C83D-F9B5-289A4C76C547}"/>
+          </ac:picMkLst>
+        </pc:picChg>
+        <pc:picChg chg="add del">
+          <ac:chgData name="Lines, Todd" userId="afaf7c3a-e8aa-4568-882a-02ad8f9e19b0" providerId="ADAL" clId="{5FF5AC1B-ABA9-43D7-A1E3-2D92732CD6E2}" dt="2026-03-19T20:38:45.521" v="67" actId="21"/>
+          <ac:picMkLst>
+            <pc:docMk/>
+            <pc:sldMk cId="1891487831" sldId="326"/>
+            <ac:picMk id="7" creationId="{7BC52C0B-5DE5-094E-7CC9-42CED7AA5B0A}"/>
+          </ac:picMkLst>
+        </pc:picChg>
+        <pc:picChg chg="del mod">
+          <ac:chgData name="Lines, Todd" userId="afaf7c3a-e8aa-4568-882a-02ad8f9e19b0" providerId="ADAL" clId="{5FF5AC1B-ABA9-43D7-A1E3-2D92732CD6E2}" dt="2026-03-19T20:38:54.623" v="69" actId="21"/>
+          <ac:picMkLst>
+            <pc:docMk/>
+            <pc:sldMk cId="1891487831" sldId="326"/>
+            <ac:picMk id="8" creationId="{CD861150-2DE4-1AE6-F3B7-0BF18D7D5BB8}"/>
+          </ac:picMkLst>
+        </pc:picChg>
+        <pc:picChg chg="add del">
+          <ac:chgData name="Lines, Todd" userId="afaf7c3a-e8aa-4568-882a-02ad8f9e19b0" providerId="ADAL" clId="{5FF5AC1B-ABA9-43D7-A1E3-2D92732CD6E2}" dt="2026-03-19T20:39:25.357" v="71" actId="21"/>
+          <ac:picMkLst>
+            <pc:docMk/>
+            <pc:sldMk cId="1891487831" sldId="326"/>
+            <ac:picMk id="10" creationId="{727F35E8-F880-5D8D-10EC-1AE8D0622D6C}"/>
+          </ac:picMkLst>
+        </pc:picChg>
+        <pc:picChg chg="del mod">
+          <ac:chgData name="Lines, Todd" userId="afaf7c3a-e8aa-4568-882a-02ad8f9e19b0" providerId="ADAL" clId="{5FF5AC1B-ABA9-43D7-A1E3-2D92732CD6E2}" dt="2026-03-19T20:39:33.640" v="73" actId="21"/>
+          <ac:picMkLst>
+            <pc:docMk/>
+            <pc:sldMk cId="1891487831" sldId="326"/>
+            <ac:picMk id="11" creationId="{2EDEE3AB-83A2-0FCB-00E1-E2A8F41C90B0}"/>
           </ac:picMkLst>
         </pc:picChg>
       </pc:sldChg>
-      <pc:sldChg chg="addSp modSp add mod">
-        <pc:chgData name="Lines, Todd" userId="afaf7c3a-e8aa-4568-882a-02ad8f9e19b0" providerId="ADAL" clId="{E4F61A1E-E133-4318-A760-48BD8E5D6B9C}" dt="2025-06-27T15:43:49.443" v="390" actId="1076"/>
+      <pc:sldChg chg="addSp delSp modSp mod">
+        <pc:chgData name="Lines, Todd" userId="afaf7c3a-e8aa-4568-882a-02ad8f9e19b0" providerId="ADAL" clId="{5FF5AC1B-ABA9-43D7-A1E3-2D92732CD6E2}" dt="2026-03-19T20:37:23.403" v="61" actId="1076"/>
         <pc:sldMkLst>
           <pc:docMk/>
           <pc:sldMk cId="809896653" sldId="327"/>
         </pc:sldMkLst>
-        <pc:spChg chg="add mod">
-          <ac:chgData name="Lines, Todd" userId="afaf7c3a-e8aa-4568-882a-02ad8f9e19b0" providerId="ADAL" clId="{E4F61A1E-E133-4318-A760-48BD8E5D6B9C}" dt="2025-06-27T15:43:38.483" v="379" actId="1076"/>
-          <ac:spMkLst>
-            <pc:docMk/>
-            <pc:sldMk cId="809896653" sldId="327"/>
-            <ac:spMk id="3" creationId="{811AED89-54DE-36A0-11FA-DD94290D13BA}"/>
-          </ac:spMkLst>
-        </pc:spChg>
-        <pc:spChg chg="add mod">
-          <ac:chgData name="Lines, Todd" userId="afaf7c3a-e8aa-4568-882a-02ad8f9e19b0" providerId="ADAL" clId="{E4F61A1E-E133-4318-A760-48BD8E5D6B9C}" dt="2025-06-27T15:43:49.443" v="390" actId="1076"/>
-          <ac:spMkLst>
-            <pc:docMk/>
-            <pc:sldMk cId="809896653" sldId="327"/>
-            <ac:spMk id="4" creationId="{22964DDF-B3B6-2C2B-61DB-ED7E38B71B1F}"/>
-          </ac:spMkLst>
-        </pc:spChg>
-        <pc:picChg chg="add mod">
-          <ac:chgData name="Lines, Todd" userId="afaf7c3a-e8aa-4568-882a-02ad8f9e19b0" providerId="ADAL" clId="{E4F61A1E-E133-4318-A760-48BD8E5D6B9C}" dt="2025-06-27T15:43:27.869" v="357" actId="14100"/>
+        <pc:picChg chg="del">
+          <ac:chgData name="Lines, Todd" userId="afaf7c3a-e8aa-4568-882a-02ad8f9e19b0" providerId="ADAL" clId="{5FF5AC1B-ABA9-43D7-A1E3-2D92732CD6E2}" dt="2026-03-19T20:37:08.928" v="58" actId="478"/>
           <ac:picMkLst>
             <pc:docMk/>
             <pc:sldMk cId="809896653" sldId="327"/>
             <ac:picMk id="2" creationId="{BE6A1B23-2511-3B38-738A-7C0FE99F73E5}"/>
           </ac:picMkLst>
         </pc:picChg>
-        <pc:picChg chg="mod">
-          <ac:chgData name="Lines, Todd" userId="afaf7c3a-e8aa-4568-882a-02ad8f9e19b0" providerId="ADAL" clId="{E4F61A1E-E133-4318-A760-48BD8E5D6B9C}" dt="2025-06-27T15:43:17.020" v="353" actId="14100"/>
+        <pc:picChg chg="del">
+          <ac:chgData name="Lines, Todd" userId="afaf7c3a-e8aa-4568-882a-02ad8f9e19b0" providerId="ADAL" clId="{5FF5AC1B-ABA9-43D7-A1E3-2D92732CD6E2}" dt="2026-03-19T20:36:47.761" v="49" actId="478"/>
           <ac:picMkLst>
             <pc:docMk/>
             <pc:sldMk cId="809896653" sldId="327"/>
             <ac:picMk id="5" creationId="{3568ACAE-F1B7-EBD1-6703-F7AAE8E64662}"/>
           </ac:picMkLst>
         </pc:picChg>
-      </pc:sldChg>
-      <pc:sldChg chg="add del">
-        <pc:chgData name="Lines, Todd" userId="afaf7c3a-e8aa-4568-882a-02ad8f9e19b0" providerId="ADAL" clId="{E4F61A1E-E133-4318-A760-48BD8E5D6B9C}" dt="2025-06-27T15:43:51.308" v="391" actId="47"/>
-        <pc:sldMkLst>
-          <pc:docMk/>
-          <pc:sldMk cId="382612236" sldId="328"/>
-        </pc:sldMkLst>
-      </pc:sldChg>
-      <pc:sldChg chg="add">
-        <pc:chgData name="Lines, Todd" userId="afaf7c3a-e8aa-4568-882a-02ad8f9e19b0" providerId="ADAL" clId="{E4F61A1E-E133-4318-A760-48BD8E5D6B9C}" dt="2025-07-01T20:50:01.081" v="392"/>
-        <pc:sldMkLst>
-          <pc:docMk/>
-          <pc:sldMk cId="0" sldId="465"/>
-        </pc:sldMkLst>
+        <pc:picChg chg="add mod">
+          <ac:chgData name="Lines, Todd" userId="afaf7c3a-e8aa-4568-882a-02ad8f9e19b0" providerId="ADAL" clId="{5FF5AC1B-ABA9-43D7-A1E3-2D92732CD6E2}" dt="2026-03-19T20:36:56.937" v="55" actId="1076"/>
+          <ac:picMkLst>
+            <pc:docMk/>
+            <pc:sldMk cId="809896653" sldId="327"/>
+            <ac:picMk id="6" creationId="{470892A6-9660-1981-20B9-43D71482A223}"/>
+          </ac:picMkLst>
+        </pc:picChg>
+        <pc:picChg chg="add mod">
+          <ac:chgData name="Lines, Todd" userId="afaf7c3a-e8aa-4568-882a-02ad8f9e19b0" providerId="ADAL" clId="{5FF5AC1B-ABA9-43D7-A1E3-2D92732CD6E2}" dt="2026-03-19T20:37:23.403" v="61" actId="1076"/>
+          <ac:picMkLst>
+            <pc:docMk/>
+            <pc:sldMk cId="809896653" sldId="327"/>
+            <ac:picMk id="7" creationId="{8071FFB2-043E-5821-F43B-2FC643C149C8}"/>
+          </ac:picMkLst>
+        </pc:picChg>
       </pc:sldChg>
     </pc:docChg>
   </pc:docChgLst>
@@ -2089,7 +1584,7 @@
           <a:p>
             <a:fld id="{696DF908-8D4D-4D2B-BE37-A5217D55DA10}" type="datetimeFigureOut">
               <a:rPr lang="en-US" smtClean="0"/>
-              <a:t>7/1/2025</a:t>
+              <a:t>3/19/2026</a:t>
             </a:fld>
             <a:endParaRPr lang="en-US"/>
           </a:p>
@@ -3545,7 +3040,7 @@
           <a:p>
             <a:fld id="{9B4E884C-4632-44AB-ABC2-E2F7AFE7F411}" type="datetimeFigureOut">
               <a:rPr lang="en-US" smtClean="0"/>
-              <a:t>7/1/2025</a:t>
+              <a:t>3/19/2026</a:t>
             </a:fld>
             <a:endParaRPr lang="en-US"/>
           </a:p>
@@ -3708,7 +3203,7 @@
           <a:p>
             <a:fld id="{9B4E884C-4632-44AB-ABC2-E2F7AFE7F411}" type="datetimeFigureOut">
               <a:rPr lang="en-US" smtClean="0"/>
-              <a:t>7/1/2025</a:t>
+              <a:t>3/19/2026</a:t>
             </a:fld>
             <a:endParaRPr lang="en-US"/>
           </a:p>
@@ -3881,7 +3376,7 @@
           <a:p>
             <a:fld id="{9B4E884C-4632-44AB-ABC2-E2F7AFE7F411}" type="datetimeFigureOut">
               <a:rPr lang="en-US" smtClean="0"/>
-              <a:t>7/1/2025</a:t>
+              <a:t>3/19/2026</a:t>
             </a:fld>
             <a:endParaRPr lang="en-US"/>
           </a:p>
@@ -4545,7 +4040,7 @@
           <a:p>
             <a:fld id="{9B4E884C-4632-44AB-ABC2-E2F7AFE7F411}" type="datetimeFigureOut">
               <a:rPr lang="en-US" smtClean="0"/>
-              <a:t>7/1/2025</a:t>
+              <a:t>3/19/2026</a:t>
             </a:fld>
             <a:endParaRPr lang="en-US"/>
           </a:p>
@@ -4785,7 +4280,7 @@
           <a:p>
             <a:fld id="{9B4E884C-4632-44AB-ABC2-E2F7AFE7F411}" type="datetimeFigureOut">
               <a:rPr lang="en-US" smtClean="0"/>
-              <a:t>7/1/2025</a:t>
+              <a:t>3/19/2026</a:t>
             </a:fld>
             <a:endParaRPr lang="en-US"/>
           </a:p>
@@ -5065,7 +4560,7 @@
           <a:p>
             <a:fld id="{9B4E884C-4632-44AB-ABC2-E2F7AFE7F411}" type="datetimeFigureOut">
               <a:rPr lang="en-US" smtClean="0"/>
-              <a:t>7/1/2025</a:t>
+              <a:t>3/19/2026</a:t>
             </a:fld>
             <a:endParaRPr lang="en-US"/>
           </a:p>
@@ -5479,7 +4974,7 @@
           <a:p>
             <a:fld id="{9B4E884C-4632-44AB-ABC2-E2F7AFE7F411}" type="datetimeFigureOut">
               <a:rPr lang="en-US" smtClean="0"/>
-              <a:t>7/1/2025</a:t>
+              <a:t>3/19/2026</a:t>
             </a:fld>
             <a:endParaRPr lang="en-US"/>
           </a:p>
@@ -5591,7 +5086,7 @@
           <a:p>
             <a:fld id="{9B4E884C-4632-44AB-ABC2-E2F7AFE7F411}" type="datetimeFigureOut">
               <a:rPr lang="en-US" smtClean="0"/>
-              <a:t>7/1/2025</a:t>
+              <a:t>3/19/2026</a:t>
             </a:fld>
             <a:endParaRPr lang="en-US"/>
           </a:p>
@@ -5681,7 +5176,7 @@
           <a:p>
             <a:fld id="{9B4E884C-4632-44AB-ABC2-E2F7AFE7F411}" type="datetimeFigureOut">
               <a:rPr lang="en-US" smtClean="0"/>
-              <a:t>7/1/2025</a:t>
+              <a:t>3/19/2026</a:t>
             </a:fld>
             <a:endParaRPr lang="en-US"/>
           </a:p>
@@ -5951,7 +5446,7 @@
           <a:p>
             <a:fld id="{9B4E884C-4632-44AB-ABC2-E2F7AFE7F411}" type="datetimeFigureOut">
               <a:rPr lang="en-US" smtClean="0"/>
-              <a:t>7/1/2025</a:t>
+              <a:t>3/19/2026</a:t>
             </a:fld>
             <a:endParaRPr lang="en-US"/>
           </a:p>
@@ -6198,7 +5693,7 @@
           <a:p>
             <a:fld id="{9B4E884C-4632-44AB-ABC2-E2F7AFE7F411}" type="datetimeFigureOut">
               <a:rPr lang="en-US" smtClean="0"/>
-              <a:t>7/1/2025</a:t>
+              <a:t>3/19/2026</a:t>
             </a:fld>
             <a:endParaRPr lang="en-US"/>
           </a:p>
@@ -6404,7 +5899,7 @@
           <a:p>
             <a:fld id="{9B4E884C-4632-44AB-ABC2-E2F7AFE7F411}" type="datetimeFigureOut">
               <a:rPr lang="en-US" smtClean="0"/>
-              <a:t>7/1/2025</a:t>
+              <a:t>3/19/2026</a:t>
             </a:fld>
             <a:endParaRPr lang="en-US"/>
           </a:p>
@@ -12462,10 +11957,10 @@
       </p:grpSpPr>
       <p:pic>
         <p:nvPicPr>
-          <p:cNvPr id="5" name="Picture 4">
+          <p:cNvPr id="4" name="Picture 3">
             <a:extLst>
               <a:ext uri="{FF2B5EF4-FFF2-40B4-BE49-F238E27FC236}">
-                <a16:creationId xmlns:a16="http://schemas.microsoft.com/office/drawing/2014/main" id="{C122EEE4-87EE-D806-AD40-EA58B31179AB}"/>
+                <a16:creationId xmlns:a16="http://schemas.microsoft.com/office/drawing/2014/main" id="{A7809F78-A3C5-82A2-407B-08F57BC00C4A}"/>
               </a:ext>
             </a:extLst>
           </p:cNvPr>
@@ -12482,8 +11977,8 @@
         </p:blipFill>
         <p:spPr>
           <a:xfrm>
-            <a:off x="1622146" y="1466850"/>
-            <a:ext cx="5899708" cy="3924300"/>
+            <a:off x="990601" y="1066800"/>
+            <a:ext cx="7132680" cy="4744434"/>
           </a:xfrm>
           <a:prstGeom prst="rect">
             <a:avLst/>
@@ -12575,7 +12070,11 @@
             <a:pPr lvl="1" eaLnBrk="1" hangingPunct="1"/>
             <a:r>
               <a:rPr lang="en-US" sz="2400" dirty="0"/>
-              <a:t>It is an exchange of energy between microscopic particles by collisions</a:t>
+              <a:t>It is an exchange of energy between microscopic particles </a:t>
+            </a:r>
+            <a:r>
+              <a:rPr lang="en-US" sz="2400" b="1" dirty="0"/>
+              <a:t>by collisions</a:t>
             </a:r>
           </a:p>
           <a:p>
@@ -12668,10 +12167,10 @@
       </p:grpSpPr>
       <p:pic>
         <p:nvPicPr>
-          <p:cNvPr id="5" name="Picture 4">
+          <p:cNvPr id="3" name="Picture 2">
             <a:extLst>
               <a:ext uri="{FF2B5EF4-FFF2-40B4-BE49-F238E27FC236}">
-                <a16:creationId xmlns:a16="http://schemas.microsoft.com/office/drawing/2014/main" id="{937426DB-B236-9CBD-7181-41B94FC7E1F1}"/>
+                <a16:creationId xmlns:a16="http://schemas.microsoft.com/office/drawing/2014/main" id="{288FAC4D-BEF0-38D3-CFD8-AF56530DC211}"/>
               </a:ext>
             </a:extLst>
           </p:cNvPr>
@@ -12688,8 +12187,8 @@
         </p:blipFill>
         <p:spPr>
           <a:xfrm>
-            <a:off x="1295400" y="1219200"/>
-            <a:ext cx="6186101" cy="4114800"/>
+            <a:off x="838201" y="762000"/>
+            <a:ext cx="7743310" cy="5150606"/>
           </a:xfrm>
           <a:prstGeom prst="rect">
             <a:avLst/>
@@ -17362,66 +16861,6 @@
           <a:chExt cx="0" cy="0"/>
         </a:xfrm>
       </p:grpSpPr>
-      <p:pic>
-        <p:nvPicPr>
-          <p:cNvPr id="5" name="Picture 4">
-            <a:extLst>
-              <a:ext uri="{FF2B5EF4-FFF2-40B4-BE49-F238E27FC236}">
-                <a16:creationId xmlns:a16="http://schemas.microsoft.com/office/drawing/2014/main" id="{3568ACAE-F1B7-EBD1-6703-F7AAE8E64662}"/>
-              </a:ext>
-            </a:extLst>
-          </p:cNvPr>
-          <p:cNvPicPr>
-            <a:picLocks noChangeAspect="1"/>
-          </p:cNvPicPr>
-          <p:nvPr/>
-        </p:nvPicPr>
-        <p:blipFill>
-          <a:blip r:embed="rId2"/>
-          <a:stretch>
-            <a:fillRect/>
-          </a:stretch>
-        </p:blipFill>
-        <p:spPr>
-          <a:xfrm>
-            <a:off x="0" y="1466850"/>
-            <a:ext cx="4553658" cy="3028950"/>
-          </a:xfrm>
-          <a:prstGeom prst="rect">
-            <a:avLst/>
-          </a:prstGeom>
-        </p:spPr>
-      </p:pic>
-      <p:pic>
-        <p:nvPicPr>
-          <p:cNvPr id="2" name="Picture 1">
-            <a:extLst>
-              <a:ext uri="{FF2B5EF4-FFF2-40B4-BE49-F238E27FC236}">
-                <a16:creationId xmlns:a16="http://schemas.microsoft.com/office/drawing/2014/main" id="{BE6A1B23-2511-3B38-738A-7C0FE99F73E5}"/>
-              </a:ext>
-            </a:extLst>
-          </p:cNvPr>
-          <p:cNvPicPr>
-            <a:picLocks noChangeAspect="1"/>
-          </p:cNvPicPr>
-          <p:nvPr/>
-        </p:nvPicPr>
-        <p:blipFill>
-          <a:blip r:embed="rId3"/>
-          <a:stretch>
-            <a:fillRect/>
-          </a:stretch>
-        </p:blipFill>
-        <p:spPr>
-          <a:xfrm>
-            <a:off x="4553658" y="1466850"/>
-            <a:ext cx="4553658" cy="3028950"/>
-          </a:xfrm>
-          <a:prstGeom prst="rect">
-            <a:avLst/>
-          </a:prstGeom>
-        </p:spPr>
-      </p:pic>
       <p:sp>
         <p:nvSpPr>
           <p:cNvPr id="3" name="TextBox 2">
@@ -17492,6 +16931,66 @@
           </a:p>
         </p:txBody>
       </p:sp>
+      <p:pic>
+        <p:nvPicPr>
+          <p:cNvPr id="6" name="Picture 5">
+            <a:extLst>
+              <a:ext uri="{FF2B5EF4-FFF2-40B4-BE49-F238E27FC236}">
+                <a16:creationId xmlns:a16="http://schemas.microsoft.com/office/drawing/2014/main" id="{470892A6-9660-1981-20B9-43D71482A223}"/>
+              </a:ext>
+            </a:extLst>
+          </p:cNvPr>
+          <p:cNvPicPr>
+            <a:picLocks noChangeAspect="1"/>
+          </p:cNvPicPr>
+          <p:nvPr/>
+        </p:nvPicPr>
+        <p:blipFill>
+          <a:blip r:embed="rId2"/>
+          <a:stretch>
+            <a:fillRect/>
+          </a:stretch>
+        </p:blipFill>
+        <p:spPr>
+          <a:xfrm>
+            <a:off x="728472" y="1720279"/>
+            <a:ext cx="3791658" cy="2522091"/>
+          </a:xfrm>
+          <a:prstGeom prst="rect">
+            <a:avLst/>
+          </a:prstGeom>
+        </p:spPr>
+      </p:pic>
+      <p:pic>
+        <p:nvPicPr>
+          <p:cNvPr id="7" name="Picture 6">
+            <a:extLst>
+              <a:ext uri="{FF2B5EF4-FFF2-40B4-BE49-F238E27FC236}">
+                <a16:creationId xmlns:a16="http://schemas.microsoft.com/office/drawing/2014/main" id="{8071FFB2-043E-5821-F43B-2FC643C149C8}"/>
+              </a:ext>
+            </a:extLst>
+          </p:cNvPr>
+          <p:cNvPicPr>
+            <a:picLocks noChangeAspect="1"/>
+          </p:cNvPicPr>
+          <p:nvPr/>
+        </p:nvPicPr>
+        <p:blipFill>
+          <a:blip r:embed="rId3"/>
+          <a:stretch>
+            <a:fillRect/>
+          </a:stretch>
+        </p:blipFill>
+        <p:spPr>
+          <a:xfrm>
+            <a:off x="4800600" y="1634650"/>
+            <a:ext cx="4049121" cy="2693348"/>
+          </a:xfrm>
+          <a:prstGeom prst="rect">
+            <a:avLst/>
+          </a:prstGeom>
+        </p:spPr>
+      </p:pic>
     </p:spTree>
     <p:extLst>
       <p:ext uri="{BB962C8B-B14F-4D97-AF65-F5344CB8AC3E}">
@@ -33451,150 +32950,349 @@
           </a:p>
         </p:txBody>
       </p:sp>
-      <p:sp>
-        <p:nvSpPr>
-          <p:cNvPr id="3" name="TextBox 2"/>
-          <p:cNvSpPr txBox="1"/>
+      <mc:AlternateContent xmlns:mc="http://schemas.openxmlformats.org/markup-compatibility/2006">
+        <mc:Choice xmlns:a14="http://schemas.microsoft.com/office/drawing/2010/main" Requires="a14">
+          <p:sp>
+            <p:nvSpPr>
+              <p:cNvPr id="6" name="Object 5"/>
+              <p:cNvSpPr txBox="1"/>
+              <p:nvPr/>
+            </p:nvSpPr>
+            <p:spPr>
+              <a:xfrm>
+                <a:off x="762000" y="4648200"/>
+                <a:ext cx="4724400" cy="1295400"/>
+              </a:xfrm>
+              <a:prstGeom prst="rect">
+                <a:avLst/>
+              </a:prstGeom>
+            </p:spPr>
+            <p:txBody>
+              <a:bodyPr>
+                <a:noAutofit/>
+              </a:bodyPr>
+              <a:lstStyle/>
+              <a:p>
+                <a:pPr/>
+                <a14:m>
+                  <m:oMathPara xmlns:m="http://schemas.openxmlformats.org/officeDocument/2006/math">
+                    <m:oMathParaPr>
+                      <m:jc m:val="left"/>
+                    </m:oMathParaPr>
+                    <m:oMath xmlns:m="http://schemas.openxmlformats.org/officeDocument/2006/math">
+                      <m:r>
+                        <a:rPr lang="en-US" sz="2800" i="1" smtClean="0">
+                          <a:solidFill>
+                            <a:srgbClr val="000000"/>
+                          </a:solidFill>
+                          <a:latin typeface="Cambria Math" panose="02040503050406030204" pitchFamily="18" charset="0"/>
+                        </a:rPr>
+                        <m:t>𝑃</m:t>
+                      </m:r>
+                      <m:r>
+                        <a:rPr lang="en-US" sz="2800" i="1" smtClean="0">
+                          <a:solidFill>
+                            <a:srgbClr val="000000"/>
+                          </a:solidFill>
+                          <a:latin typeface="Cambria Math" panose="02040503050406030204" pitchFamily="18" charset="0"/>
+                        </a:rPr>
+                        <m:t>=</m:t>
+                      </m:r>
+                      <m:f>
+                        <m:fPr>
+                          <m:ctrlPr>
+                            <a:rPr lang="en-US" sz="2800" i="1">
+                              <a:solidFill>
+                                <a:srgbClr val="000000"/>
+                              </a:solidFill>
+                              <a:latin typeface="Cambria Math" panose="02040503050406030204" pitchFamily="18" charset="0"/>
+                            </a:rPr>
+                          </m:ctrlPr>
+                        </m:fPr>
+                        <m:num>
+                          <m:r>
+                            <a:rPr lang="en-US" sz="2800" i="1">
+                              <a:solidFill>
+                                <a:srgbClr val="000000"/>
+                              </a:solidFill>
+                              <a:latin typeface="Cambria Math" panose="02040503050406030204" pitchFamily="18" charset="0"/>
+                            </a:rPr>
+                            <m:t>𝑄</m:t>
+                          </m:r>
+                        </m:num>
+                        <m:den>
+                          <m:r>
+                            <m:rPr>
+                              <m:sty m:val="p"/>
+                            </m:rPr>
+                            <a:rPr lang="en-US" sz="2800" i="1">
+                              <a:solidFill>
+                                <a:srgbClr val="000000"/>
+                              </a:solidFill>
+                              <a:latin typeface="Cambria Math" panose="02040503050406030204" pitchFamily="18" charset="0"/>
+                            </a:rPr>
+                            <m:t>Δ</m:t>
+                          </m:r>
+                          <m:r>
+                            <a:rPr lang="en-US" sz="2800" i="1">
+                              <a:solidFill>
+                                <a:srgbClr val="000000"/>
+                              </a:solidFill>
+                              <a:latin typeface="Cambria Math" panose="02040503050406030204" pitchFamily="18" charset="0"/>
+                            </a:rPr>
+                            <m:t>𝑡</m:t>
+                          </m:r>
+                        </m:den>
+                      </m:f>
+                      <m:r>
+                        <a:rPr lang="en-US" sz="2800" i="1">
+                          <a:solidFill>
+                            <a:srgbClr val="000000"/>
+                          </a:solidFill>
+                          <a:latin typeface="Cambria Math" panose="02040503050406030204" pitchFamily="18" charset="0"/>
+                        </a:rPr>
+                        <m:t>=</m:t>
+                      </m:r>
+                      <m:sSub>
+                        <m:sSubPr>
+                          <m:ctrlPr>
+                            <a:rPr lang="en-US" sz="2800" i="1" smtClean="0">
+                              <a:solidFill>
+                                <a:srgbClr val="000000"/>
+                              </a:solidFill>
+                              <a:latin typeface="Cambria Math" panose="02040503050406030204" pitchFamily="18" charset="0"/>
+                            </a:rPr>
+                          </m:ctrlPr>
+                        </m:sSubPr>
+                        <m:e>
+                          <m:r>
+                            <a:rPr lang="en-US" sz="2800" b="0" i="1" smtClean="0">
+                              <a:solidFill>
+                                <a:srgbClr val="000000"/>
+                              </a:solidFill>
+                              <a:latin typeface="Cambria Math" panose="02040503050406030204" pitchFamily="18" charset="0"/>
+                            </a:rPr>
+                            <m:t>𝑘</m:t>
+                          </m:r>
+                        </m:e>
+                        <m:sub>
+                          <m:r>
+                            <a:rPr lang="en-US" sz="2800" b="0" i="1" smtClean="0">
+                              <a:solidFill>
+                                <a:srgbClr val="000000"/>
+                              </a:solidFill>
+                              <a:latin typeface="Cambria Math" panose="02040503050406030204" pitchFamily="18" charset="0"/>
+                            </a:rPr>
+                            <m:t>𝑡h𝑒𝑟𝑚</m:t>
+                          </m:r>
+                        </m:sub>
+                      </m:sSub>
+                      <m:r>
+                        <a:rPr lang="en-US" sz="2800" i="1">
+                          <a:solidFill>
+                            <a:srgbClr val="000000"/>
+                          </a:solidFill>
+                          <a:latin typeface="Cambria Math" panose="02040503050406030204" pitchFamily="18" charset="0"/>
+                        </a:rPr>
+                        <m:t>𝐴</m:t>
+                      </m:r>
+                      <m:f>
+                        <m:fPr>
+                          <m:ctrlPr>
+                            <a:rPr lang="en-US" sz="2800" i="1">
+                              <a:solidFill>
+                                <a:srgbClr val="000000"/>
+                              </a:solidFill>
+                              <a:latin typeface="Cambria Math" panose="02040503050406030204" pitchFamily="18" charset="0"/>
+                            </a:rPr>
+                          </m:ctrlPr>
+                        </m:fPr>
+                        <m:num>
+                          <m:sSub>
+                            <m:sSubPr>
+                              <m:ctrlPr>
+                                <a:rPr lang="en-US" sz="2800" i="1">
+                                  <a:solidFill>
+                                    <a:srgbClr val="000000"/>
+                                  </a:solidFill>
+                                  <a:latin typeface="Cambria Math" panose="02040503050406030204" pitchFamily="18" charset="0"/>
+                                </a:rPr>
+                              </m:ctrlPr>
+                            </m:sSubPr>
+                            <m:e>
+                              <m:r>
+                                <a:rPr lang="en-US" sz="2800" i="1">
+                                  <a:solidFill>
+                                    <a:srgbClr val="000000"/>
+                                  </a:solidFill>
+                                  <a:latin typeface="Cambria Math" panose="02040503050406030204" pitchFamily="18" charset="0"/>
+                                </a:rPr>
+                                <m:t>𝑇</m:t>
+                              </m:r>
+                            </m:e>
+                            <m:sub>
+                              <m:r>
+                                <a:rPr lang="en-US" sz="2800" i="1">
+                                  <a:solidFill>
+                                    <a:srgbClr val="000000"/>
+                                  </a:solidFill>
+                                  <a:latin typeface="Cambria Math" panose="02040503050406030204" pitchFamily="18" charset="0"/>
+                                </a:rPr>
+                                <m:t>h</m:t>
+                              </m:r>
+                            </m:sub>
+                          </m:sSub>
+                          <m:r>
+                            <a:rPr lang="en-US" sz="2800" i="1">
+                              <a:solidFill>
+                                <a:srgbClr val="000000"/>
+                              </a:solidFill>
+                              <a:latin typeface="Cambria Math" panose="02040503050406030204" pitchFamily="18" charset="0"/>
+                            </a:rPr>
+                            <m:t>−</m:t>
+                          </m:r>
+                          <m:sSub>
+                            <m:sSubPr>
+                              <m:ctrlPr>
+                                <a:rPr lang="en-US" sz="2800" i="1">
+                                  <a:solidFill>
+                                    <a:srgbClr val="000000"/>
+                                  </a:solidFill>
+                                  <a:latin typeface="Cambria Math" panose="02040503050406030204" pitchFamily="18" charset="0"/>
+                                </a:rPr>
+                              </m:ctrlPr>
+                            </m:sSubPr>
+                            <m:e>
+                              <m:r>
+                                <a:rPr lang="en-US" sz="2800" i="1">
+                                  <a:solidFill>
+                                    <a:srgbClr val="000000"/>
+                                  </a:solidFill>
+                                  <a:latin typeface="Cambria Math" panose="02040503050406030204" pitchFamily="18" charset="0"/>
+                                </a:rPr>
+                                <m:t>𝑇</m:t>
+                              </m:r>
+                            </m:e>
+                            <m:sub>
+                              <m:r>
+                                <a:rPr lang="en-US" sz="2800" i="1">
+                                  <a:solidFill>
+                                    <a:srgbClr val="000000"/>
+                                  </a:solidFill>
+                                  <a:latin typeface="Cambria Math" panose="02040503050406030204" pitchFamily="18" charset="0"/>
+                                </a:rPr>
+                                <m:t>𝑐</m:t>
+                              </m:r>
+                            </m:sub>
+                          </m:sSub>
+                        </m:num>
+                        <m:den>
+                          <m:r>
+                            <m:rPr>
+                              <m:sty m:val="p"/>
+                            </m:rPr>
+                            <a:rPr lang="en-US" sz="2800" i="1">
+                              <a:solidFill>
+                                <a:srgbClr val="000000"/>
+                              </a:solidFill>
+                              <a:latin typeface="Cambria Math" panose="02040503050406030204" pitchFamily="18" charset="0"/>
+                            </a:rPr>
+                            <m:t>Δ</m:t>
+                          </m:r>
+                          <m:r>
+                            <a:rPr lang="en-US" sz="2800" i="1">
+                              <a:solidFill>
+                                <a:srgbClr val="000000"/>
+                              </a:solidFill>
+                              <a:latin typeface="Cambria Math" panose="02040503050406030204" pitchFamily="18" charset="0"/>
+                            </a:rPr>
+                            <m:t>𝐿</m:t>
+                          </m:r>
+                        </m:den>
+                      </m:f>
+                    </m:oMath>
+                  </m:oMathPara>
+                </a14:m>
+                <a:endParaRPr lang="en-US" sz="2800" dirty="0"/>
+              </a:p>
+            </p:txBody>
+          </p:sp>
+        </mc:Choice>
+        <mc:Fallback>
+          <p:sp>
+            <p:nvSpPr>
+              <p:cNvPr id="6" name="Object 5"/>
+              <p:cNvSpPr txBox="1">
+                <a:spLocks noRot="1" noChangeAspect="1" noMove="1" noResize="1" noEditPoints="1" noAdjustHandles="1" noChangeArrowheads="1" noChangeShapeType="1" noTextEdit="1"/>
+              </p:cNvSpPr>
+              <p:nvPr/>
+            </p:nvSpPr>
+            <p:spPr>
+              <a:xfrm>
+                <a:off x="762000" y="4648200"/>
+                <a:ext cx="4724400" cy="1295400"/>
+              </a:xfrm>
+              <a:prstGeom prst="rect">
+                <a:avLst/>
+              </a:prstGeom>
+              <a:blipFill>
+                <a:blip r:embed="rId2"/>
+                <a:stretch>
+                  <a:fillRect/>
+                </a:stretch>
+              </a:blipFill>
+            </p:spPr>
+            <p:txBody>
+              <a:bodyPr/>
+              <a:lstStyle/>
+              <a:p>
+                <a:r>
+                  <a:rPr lang="en-US">
+                    <a:noFill/>
+                  </a:rPr>
+                  <a:t> </a:t>
+                </a:r>
+              </a:p>
+            </p:txBody>
+          </p:sp>
+        </mc:Fallback>
+      </mc:AlternateContent>
+      <p:pic>
+        <p:nvPicPr>
+          <p:cNvPr id="10" name="Graphic 9">
+            <a:extLst>
+              <a:ext uri="{FF2B5EF4-FFF2-40B4-BE49-F238E27FC236}">
+                <a16:creationId xmlns:a16="http://schemas.microsoft.com/office/drawing/2014/main" id="{792FC827-A1F7-B12C-79D4-C253C5889CF4}"/>
+              </a:ext>
+            </a:extLst>
+          </p:cNvPr>
+          <p:cNvPicPr>
+            <a:picLocks noChangeAspect="1"/>
+          </p:cNvPicPr>
           <p:nvPr/>
-        </p:nvSpPr>
+        </p:nvPicPr>
+        <p:blipFill>
+          <a:blip r:embed="rId3">
+            <a:extLst>
+              <a:ext uri="{96DAC541-7B7A-43D3-8B79-37D633B846F1}">
+                <asvg:svgBlip xmlns:asvg="http://schemas.microsoft.com/office/drawing/2016/SVG/main" r:embed="rId4"/>
+              </a:ext>
+            </a:extLst>
+          </a:blip>
+          <a:stretch>
+            <a:fillRect/>
+          </a:stretch>
+        </p:blipFill>
         <p:spPr>
           <a:xfrm>
-            <a:off x="8077200" y="685800"/>
-            <a:ext cx="317716" cy="369332"/>
+            <a:off x="5181600" y="1710452"/>
+            <a:ext cx="3269343" cy="4038600"/>
           </a:xfrm>
           <a:prstGeom prst="rect">
             <a:avLst/>
           </a:prstGeom>
-          <a:noFill/>
-        </p:spPr>
-        <p:txBody>
-          <a:bodyPr wrap="none" rtlCol="0">
-            <a:spAutoFit/>
-          </a:bodyPr>
-          <a:lstStyle/>
-          <a:p>
-            <a:r>
-              <a:rPr lang="en-US" dirty="0"/>
-              <a:t>A</a:t>
-            </a:r>
-          </a:p>
-        </p:txBody>
-      </p:sp>
-      <p:pic>
-        <p:nvPicPr>
-          <p:cNvPr id="1033" name="Picture 9"/>
-          <p:cNvPicPr>
-            <a:picLocks noChangeAspect="1" noChangeArrowheads="1"/>
-          </p:cNvPicPr>
-          <p:nvPr/>
-        </p:nvPicPr>
-        <p:blipFill>
-          <a:blip r:embed="rId2" cstate="print">
-            <a:extLst>
-              <a:ext uri="{28A0092B-C50C-407E-A947-70E740481C1C}">
-                <a14:useLocalDpi xmlns:a14="http://schemas.microsoft.com/office/drawing/2010/main" val="0"/>
-              </a:ext>
-            </a:extLst>
-          </a:blip>
-          <a:srcRect/>
-          <a:stretch>
-            <a:fillRect/>
-          </a:stretch>
-        </p:blipFill>
-        <p:spPr bwMode="auto">
-          <a:xfrm>
-            <a:off x="4976446" y="1219200"/>
-            <a:ext cx="3124200" cy="5024321"/>
-          </a:xfrm>
-          <a:prstGeom prst="rect">
-            <a:avLst/>
-          </a:prstGeom>
-          <a:noFill/>
-          <a:ln>
-            <a:noFill/>
-          </a:ln>
-          <a:effectLst/>
-          <a:extLst>
-            <a:ext uri="{909E8E84-426E-40DD-AFC4-6F175D3DCCD1}">
-              <a14:hiddenFill xmlns:a14="http://schemas.microsoft.com/office/drawing/2010/main">
-                <a:solidFill>
-                  <a:schemeClr val="accent1"/>
-                </a:solidFill>
-              </a14:hiddenFill>
-            </a:ext>
-            <a:ext uri="{91240B29-F687-4F45-9708-019B960494DF}">
-              <a14:hiddenLine xmlns:a14="http://schemas.microsoft.com/office/drawing/2010/main" w="9525">
-                <a:solidFill>
-                  <a:schemeClr val="tx1"/>
-                </a:solidFill>
-                <a:miter lim="800000"/>
-                <a:headEnd/>
-                <a:tailEnd/>
-              </a14:hiddenLine>
-            </a:ext>
-            <a:ext uri="{AF507438-7753-43E0-B8FC-AC1667EBCBE1}">
-              <a14:hiddenEffects xmlns:a14="http://schemas.microsoft.com/office/drawing/2010/main">
-                <a:effectLst>
-                  <a:outerShdw dist="35921" dir="2700000" algn="ctr" rotWithShape="0">
-                    <a:schemeClr val="bg2"/>
-                  </a:outerShdw>
-                </a:effectLst>
-              </a14:hiddenEffects>
-            </a:ext>
-          </a:extLst>
         </p:spPr>
       </p:pic>
-      <p:graphicFrame>
-        <p:nvGraphicFramePr>
-          <p:cNvPr id="6" name="Object 5"/>
-          <p:cNvGraphicFramePr>
-            <a:graphicFrameLocks noChangeAspect="1"/>
-          </p:cNvGraphicFramePr>
-          <p:nvPr/>
-        </p:nvGraphicFramePr>
-        <p:xfrm>
-          <a:off x="762000" y="4343400"/>
-          <a:ext cx="4011561" cy="1295400"/>
-        </p:xfrm>
-        <a:graphic>
-          <a:graphicData uri="http://schemas.openxmlformats.org/presentationml/2006/ole">
-            <mc:AlternateContent xmlns:mc="http://schemas.openxmlformats.org/markup-compatibility/2006">
-              <mc:Choice xmlns:v="urn:schemas-microsoft-com:vml" Requires="v">
-                <p:oleObj name="Equation" r:id="rId3" imgW="1218960" imgH="393480" progId="Equation.3">
-                  <p:embed/>
-                </p:oleObj>
-              </mc:Choice>
-              <mc:Fallback>
-                <p:oleObj name="Equation" r:id="rId3" imgW="1218960" imgH="393480" progId="Equation.3">
-                  <p:embed/>
-                  <p:pic>
-                    <p:nvPicPr>
-                      <p:cNvPr id="6" name="Object 5"/>
-                      <p:cNvPicPr/>
-                      <p:nvPr/>
-                    </p:nvPicPr>
-                    <p:blipFill>
-                      <a:blip r:embed="rId4"/>
-                      <a:stretch>
-                        <a:fillRect/>
-                      </a:stretch>
-                    </p:blipFill>
-                    <p:spPr>
-                      <a:xfrm>
-                        <a:off x="762000" y="4343400"/>
-                        <a:ext cx="4011561" cy="1295400"/>
-                      </a:xfrm>
-                      <a:prstGeom prst="rect">
-                        <a:avLst/>
-                      </a:prstGeom>
-                    </p:spPr>
-                  </p:pic>
-                </p:oleObj>
-              </mc:Fallback>
-            </mc:AlternateContent>
-          </a:graphicData>
-        </a:graphic>
-      </p:graphicFrame>
     </p:spTree>
   </p:cSld>
   <p:clrMapOvr>

</xml_diff>